<commit_message>
70/15/15 re-split with duplicates removed, overfitting check, rerun protocol experiments
- src/split_701515.py: remove 170,596 duplicate flows, split each router
  70/15/15 (train/validation/test), scaler fit on train only
- src/split_experiment.py: centralized + FedAvg with train/val/test
  accuracy and loss curves (no overfitting: equal on all three)
- protocol_experiment.py, defense_experiment.py: KRYPSIS_SPLIT=701515
  switch to run on the new split
- results/split_701515/: new results; Mondrian thresholds now beat the
  global threshold (70.0% vs 29.5% caught, p < 0.001)
- README Phase 12 and final-review deck updated with the new numbers
</commit_message>
<xml_diff>
--- a/presentation/Krypsis_Final_Review.pptx
+++ b/presentation/Krypsis_Final_Review.pptx
@@ -190,7 +190,7 @@
                 <c:formatCode>General</c:formatCode>
                 <c:ptCount val="2"/>
                 <c:pt idx="0">
-                  <c:v>92.35561258507254</c:v>
+                  <c:v>82.56405042700285</c:v>
                 </c:pt>
                 <c:pt idx="1">
                   <c:v>68.76863023420864</c:v>
@@ -208,7 +208,56 @@
               <c:strCache>
                 <c:ptCount val="1"/>
                 <c:pt idx="0">
-                  <c:v>With Krypsis</c:v>
+                  <c:v>Krypsis v2 global</c:v>
+                </c:pt>
+              </c:strCache>
+            </c:strRef>
+          </c:tx>
+          <c:spPr>
+            <a:solidFill>
+              <a:srgbClr val="C97A2B"/>
+            </a:solidFill>
+          </c:spPr>
+          <c:cat>
+            <c:strRef>
+              <c:f>Sheet1!$A$2:$A$3</c:f>
+              <c:strCache>
+                <c:ptCount val="2"/>
+                <c:pt idx="0">
+                  <c:v>FLNET2023</c:v>
+                </c:pt>
+                <c:pt idx="1">
+                  <c:v>NSL-KDD</c:v>
+                </c:pt>
+              </c:strCache>
+            </c:strRef>
+          </c:cat>
+          <c:val>
+            <c:numRef>
+              <c:f>Sheet1!$C$2:$C$3</c:f>
+              <c:numCache>
+                <c:formatCode>General</c:formatCode>
+                <c:ptCount val="2"/>
+                <c:pt idx="0">
+                  <c:v>83.82099769554019</c:v>
+                </c:pt>
+                <c:pt idx="1">
+                  <c:v>79.15498580553584</c:v>
+                </c:pt>
+              </c:numCache>
+            </c:numRef>
+          </c:val>
+        </c:ser>
+        <c:ser>
+          <c:idx val="2"/>
+          <c:order val="2"/>
+          <c:tx>
+            <c:strRef>
+              <c:f>Sheet1!$D$1</c:f>
+              <c:strCache>
+                <c:ptCount val="1"/>
+                <c:pt idx="0">
+                  <c:v>Krypsis v2 Mondrian</c:v>
                 </c:pt>
               </c:strCache>
             </c:strRef>
@@ -234,15 +283,15 @@
           </c:cat>
           <c:val>
             <c:numRef>
-              <c:f>Sheet1!$C$2:$C$3</c:f>
+              <c:f>Sheet1!$D$2:$D$3</c:f>
               <c:numCache>
                 <c:formatCode>General</c:formatCode>
                 <c:ptCount val="2"/>
                 <c:pt idx="0">
-                  <c:v>96.72742826231901</c:v>
+                  <c:v>99.97017757896162</c:v>
                 </c:pt>
                 <c:pt idx="1">
-                  <c:v>79.15498580553584</c:v>
+                  <c:v>78.66926898509581</c:v>
                 </c:pt>
               </c:numCache>
             </c:numRef>
@@ -415,7 +464,7 @@
                 </a:solidFill>
                 <a:latin typeface="Calibri"/>
               </a:rPr>
-              <a:t>Naming the attack type (11 classes): macro-F1</a:t>
+              <a:t>No overfitting: train vs validation vs test</a:t>
             </a:r>
           </a:p>
         </c:rich>
@@ -437,7 +486,56 @@
               <c:strCache>
                 <c:ptCount val="1"/>
                 <c:pt idx="0">
-                  <c:v>Macro-F1</c:v>
+                  <c:v>Train 70%</c:v>
+                </c:pt>
+              </c:strCache>
+            </c:strRef>
+          </c:tx>
+          <c:spPr>
+            <a:solidFill>
+              <a:srgbClr val="8A968F"/>
+            </a:solidFill>
+          </c:spPr>
+          <c:cat>
+            <c:strRef>
+              <c:f>Sheet1!$A$2:$A$3</c:f>
+              <c:strCache>
+                <c:ptCount val="2"/>
+                <c:pt idx="0">
+                  <c:v>Centralized</c:v>
+                </c:pt>
+                <c:pt idx="1">
+                  <c:v>FedAvg, 10 routers</c:v>
+                </c:pt>
+              </c:strCache>
+            </c:strRef>
+          </c:cat>
+          <c:val>
+            <c:numRef>
+              <c:f>Sheet1!$B$2:$B$3</c:f>
+              <c:numCache>
+                <c:formatCode>General</c:formatCode>
+                <c:ptCount val="2"/>
+                <c:pt idx="0">
+                  <c:v>99.99891060022297</c:v>
+                </c:pt>
+                <c:pt idx="1">
+                  <c:v>99.96768113994793</c:v>
+                </c:pt>
+              </c:numCache>
+            </c:numRef>
+          </c:val>
+        </c:ser>
+        <c:ser>
+          <c:idx val="1"/>
+          <c:order val="1"/>
+          <c:tx>
+            <c:strRef>
+              <c:f>Sheet1!$C$1</c:f>
+              <c:strCache>
+                <c:ptCount val="1"/>
+                <c:pt idx="0">
+                  <c:v>Validation 15%</c:v>
                 </c:pt>
               </c:strCache>
             </c:strRef>
@@ -449,42 +547,85 @@
           </c:spPr>
           <c:cat>
             <c:strRef>
-              <c:f>Sheet1!$A$2:$A$4</c:f>
+              <c:f>Sheet1!$A$2:$A$3</c:f>
               <c:strCache>
-                <c:ptCount val="3"/>
+                <c:ptCount val="2"/>
                 <c:pt idx="0">
                   <c:v>Centralized</c:v>
                 </c:pt>
                 <c:pt idx="1">
-                  <c:v>FedAvg IID</c:v>
-                </c:pt>
-                <c:pt idx="2">
-                  <c:v>FedAvg routers</c:v>
+                  <c:v>FedAvg, 10 routers</c:v>
                 </c:pt>
               </c:strCache>
             </c:strRef>
           </c:cat>
           <c:val>
             <c:numRef>
-              <c:f>Sheet1!$B$2:$B$4</c:f>
+              <c:f>Sheet1!$C$2:$C$3</c:f>
               <c:numCache>
                 <c:formatCode>General</c:formatCode>
-                <c:ptCount val="3"/>
+                <c:ptCount val="2"/>
                 <c:pt idx="0">
-                  <c:v>78.9875770383257</c:v>
+                  <c:v>99.99830542940418</c:v>
                 </c:pt>
                 <c:pt idx="1">
-                  <c:v>75.88834627427782</c:v>
+                  <c:v>99.97119229987122</c:v>
                 </c:pt>
-                <c:pt idx="2">
-                  <c:v>38.89182280782382</c:v>
+              </c:numCache>
+            </c:numRef>
+          </c:val>
+        </c:ser>
+        <c:ser>
+          <c:idx val="2"/>
+          <c:order val="2"/>
+          <c:tx>
+            <c:strRef>
+              <c:f>Sheet1!$D$1</c:f>
+              <c:strCache>
+                <c:ptCount val="1"/>
+                <c:pt idx="0">
+                  <c:v>Test 15%</c:v>
+                </c:pt>
+              </c:strCache>
+            </c:strRef>
+          </c:tx>
+          <c:spPr>
+            <a:solidFill>
+              <a:srgbClr val="146B62"/>
+            </a:solidFill>
+          </c:spPr>
+          <c:cat>
+            <c:strRef>
+              <c:f>Sheet1!$A$2:$A$3</c:f>
+              <c:strCache>
+                <c:ptCount val="2"/>
+                <c:pt idx="0">
+                  <c:v>Centralized</c:v>
+                </c:pt>
+                <c:pt idx="1">
+                  <c:v>FedAvg, 10 routers</c:v>
+                </c:pt>
+              </c:strCache>
+            </c:strRef>
+          </c:cat>
+          <c:val>
+            <c:numRef>
+              <c:f>Sheet1!$D$2:$D$3</c:f>
+              <c:numCache>
+                <c:formatCode>General</c:formatCode>
+                <c:ptCount val="2"/>
+                <c:pt idx="0">
+                  <c:v>99.99830554425918</c:v>
+                </c:pt>
+                <c:pt idx="1">
+                  <c:v>99.96272197370205</c:v>
                 </c:pt>
               </c:numCache>
             </c:numRef>
           </c:val>
         </c:ser>
         <c:dLbls>
-          <c:numFmt formatCode="0&quot;%&quot;" sourceLinked="0"/>
+          <c:numFmt formatCode="0.00&quot;%&quot;" sourceLinked="0"/>
           <c:txPr>
             <a:bodyPr/>
             <a:lstStyle/>
@@ -593,6 +734,23 @@
         <c:majorUnit val="20.0"/>
       </c:valAx>
     </c:plotArea>
+    <c:legend>
+      <c:legendPos val="b"/>
+      <c:overlay val="0"/>
+      <c:txPr>
+        <a:bodyPr/>
+        <a:lstStyle/>
+        <a:p>
+          <a:pPr>
+            <a:defRPr>
+              <a:solidFill>
+                <a:srgbClr val="56655D"/>
+              </a:solidFill>
+            </a:defRPr>
+          </a:pPr>
+        </a:p>
+      </c:txPr>
+    </c:legend>
     <c:dispBlanksAs val="gap"/>
   </c:chart>
   <c:txPr>
@@ -1346,62 +1504,77 @@
           </a:p>
           <a:p>
             <a:r>
-              <a:t>99.93%, almost the same as the centralized</a:t>
-            </a:r>
-          </a:p>
-          <a:p>
-            <a:r>
-              <a:t>100.0%. Every one of the 105 tampered messages was rejected. Under</a:t>
-            </a:r>
-          </a:p>
-          <a:p>
-            <a:r>
-              <a:t>the label-flipping attack the protocol caught 71.4% of</a:t>
-            </a:r>
-          </a:p>
-          <a:p>
-            <a:r>
-              <a:t>poisoned updates on FLNET2023 and 99.3% on NSL-KDD,</a:t>
-            </a:r>
-          </a:p>
-          <a:p>
-            <a:r>
-              <a:t>while wrongly flagging under 1.2 percent of honest ones.</a:t>
-            </a:r>
-          </a:p>
-          <a:p>
-            <a:r>
-              <a:t>Bottom left: accuracy at the end of an attacked run, without and with Krypsis:</a:t>
-            </a:r>
-          </a:p>
-          <a:p>
-            <a:r>
-              <a:t>FLNET2023 92.4% to 96.7%, NSL-KDD</a:t>
-            </a:r>
-          </a:p>
-          <a:p>
-            <a:r>
-              <a:t>68.8% to 79.2%; the NSL-KDD gain is</a:t>
-            </a:r>
-          </a:p>
-          <a:p>
-            <a:r>
-              <a:t>statistically significant, p = 0.009.</a:t>
-            </a:r>
-          </a:p>
-          <a:p>
-            <a:r>
-              <a:t>Bottom right: the binary task is easy, so we also named the 11 traffic types. There,</a:t>
-            </a:r>
-          </a:p>
-          <a:p>
-            <a:r>
-              <a:t>real uneven routers drop macro-F1 from 0.76 to 0.39: attack types that only one</a:t>
-            </a:r>
-          </a:p>
-          <a:p>
-            <a:r>
-              <a:t>router sees get averaged away. That is the cost of non-IID data.</a:t>
+              <a:t>99.96% on the test set, with the same accuracy on training and</a:t>
+            </a:r>
+          </a:p>
+          <a:p>
+            <a:r>
+              <a:t>validation data. Every one of the 105 tampered messages was rejected. Under the</a:t>
+            </a:r>
+          </a:p>
+          <a:p>
+            <a:r>
+              <a:t>label-flipping attack, Krypsis v2 with Mondrian thresholds caught</a:t>
+            </a:r>
+          </a:p>
+          <a:p>
+            <a:r>
+              <a:t>74.3% of poisoned updates on FLNET2023 and</a:t>
+            </a:r>
+          </a:p>
+          <a:p>
+            <a:r>
+              <a:t>99.3% on NSL-KDD, while wrongly excluding under</a:t>
+            </a:r>
+          </a:p>
+          <a:p>
+            <a:r>
+              <a:t>2 percent of honest ones.</a:t>
+            </a:r>
+          </a:p>
+          <a:p>
+            <a:r>
+              <a:t>Bottom left: accuracy at the end of an attacked run. On FLNET2023 no protocol gives</a:t>
+            </a:r>
+          </a:p>
+          <a:p>
+            <a:r>
+              <a:t>82.6%, the global threshold</a:t>
+            </a:r>
+          </a:p>
+          <a:p>
+            <a:r>
+              <a:t>83.8%, and Mondrian 100.0%,</a:t>
+            </a:r>
+          </a:p>
+          <a:p>
+            <a:r>
+              <a:t>a significant gain, p = 0.045. On NSL-KDD both versions lift accuracy from</a:t>
+            </a:r>
+          </a:p>
+          <a:p>
+            <a:r>
+              <a:t>68.8% to about 79.2%.</a:t>
+            </a:r>
+          </a:p>
+          <a:p>
+            <a:r>
+              <a:t>Bottom right: the overfitting check. With the 70, 15, 15 split</a:t>
+            </a:r>
+          </a:p>
+          <a:p>
+            <a:r>
+              <a:t>and duplicates removed, training, validation and test accuracy are the same, for the</a:t>
+            </a:r>
+          </a:p>
+          <a:p>
+            <a:r>
+              <a:t>centralized model and for FedAvg. The model is not memorising; this dataset is simply</a:t>
+            </a:r>
+          </a:p>
+          <a:p>
+            <a:r>
+              <a:t>easy to separate.</a:t>
             </a:r>
           </a:p>
         </p:txBody>
@@ -1476,42 +1649,77 @@
           </a:p>
           <a:p>
             <a:r>
-              <a:t>FLNET2023. Without the protocol, accuracy under attack ends at</a:t>
-            </a:r>
-          </a:p>
-          <a:p>
-            <a:r>
-              <a:t>78.0%. With the protocol and a global threshold it is</a:t>
-            </a:r>
-          </a:p>
-          <a:p>
-            <a:r>
-              <a:t>88.2%; with Mondrian 87.5%. Mondrian</a:t>
-            </a:r>
-          </a:p>
-          <a:p>
-            <a:r>
-              <a:t>caught slightly more attacks, 57.6% against</a:t>
-            </a:r>
-          </a:p>
-          <a:p>
-            <a:r>
-              <a:t>53.3%, but also wrongly flagged more honest clients,</a:t>
-            </a:r>
-          </a:p>
-          <a:p>
-            <a:r>
-              <a:t>4.6% against 2.7%. Paired</a:t>
-            </a:r>
-          </a:p>
-          <a:p>
-            <a:r>
-              <a:t>t-tests over the 15 seeds show neither difference is significant. So the simpler</a:t>
-            </a:r>
-          </a:p>
-          <a:p>
-            <a:r>
-              <a:t>global threshold is the best choice, and both rejected every tampered message.</a:t>
+              <a:t>FLNET2023. Because accuracy swings from round to round while attackers are active, the</a:t>
+            </a:r>
+          </a:p>
+          <a:p>
+            <a:r>
+              <a:t>first row is the mean over the attack rounds 6 to 12: 81.9% with no</a:t>
+            </a:r>
+          </a:p>
+          <a:p>
+            <a:r>
+              <a:t>protocol, 85.0% with a global threshold and</a:t>
+            </a:r>
+          </a:p>
+          <a:p>
+            <a:r>
+              <a:t>94.6% with Mondrian; Mondrian is significantly better than both</a:t>
+            </a:r>
+          </a:p>
+          <a:p>
+            <a:r>
+              <a:t>(p = 0.002 and p = 0.007).</a:t>
+            </a:r>
+          </a:p>
+          <a:p>
+            <a:r>
+              <a:t>Mondrian caught 70.0% of attacks against</a:t>
+            </a:r>
+          </a:p>
+          <a:p>
+            <a:r>
+              <a:t>29.5% for the global threshold. Its cost is more honest</a:t>
+            </a:r>
+          </a:p>
+          <a:p>
+            <a:r>
+              <a:t>updates flagged, 12.9% against</a:t>
+            </a:r>
+          </a:p>
+          <a:p>
+            <a:r>
+              <a:t>2.0%, because this experiment simply drops flagged</a:t>
+            </a:r>
+          </a:p>
+          <a:p>
+            <a:r>
+              <a:t>updates. In Krypsis v2 the second check rescues most of them: only</a:t>
+            </a:r>
+          </a:p>
+          <a:p>
+            <a:r>
+              <a:t>0.7% of honest updates are lost.</a:t>
+            </a:r>
+          </a:p>
+          <a:p>
+            <a:r>
+              <a:t>Why does Mondrian win? After removing duplicates the routers are very different: router</a:t>
+            </a:r>
+          </a:p>
+          <a:p>
+            <a:r>
+              <a:t>3 is under half attack traffic, most others about 90 percent. One global line must be</a:t>
+            </a:r>
+          </a:p>
+          <a:p>
+            <a:r>
+              <a:t>loose enough for router 3, so it misses attackers; per-cluster lines can be strict</a:t>
+            </a:r>
+          </a:p>
+          <a:p>
+            <a:r>
+              <a:t>where it is safe. Both versions rejected every tampered message.</a:t>
             </a:r>
           </a:p>
         </p:txBody>
@@ -1596,27 +1804,37 @@
           </a:p>
           <a:p>
             <a:r>
-              <a:t>Federated training almost matches centralized training, and under attack Krypsis</a:t>
-            </a:r>
-          </a:p>
-          <a:p>
-            <a:r>
-              <a:t>keeps accuracy higher. Our research finding: one global threshold is enough; the</a:t>
-            </a:r>
-          </a:p>
-          <a:p>
-            <a:r>
-              <a:t>per-cluster Mondrian threshold gave no significant gain. Next we would run the</a:t>
-            </a:r>
-          </a:p>
-          <a:p>
-            <a:r>
-              <a:t>protocol on the 11-class task, use a trust-based weight cap, and test on a real</a:t>
-            </a:r>
-          </a:p>
-          <a:p>
-            <a:r>
-              <a:t>network. The key references are on the right, and all the code and results are on</a:t>
+              <a:t>Federated training matches centralized training, and on a fair 70, 15, 15 split with</a:t>
+            </a:r>
+          </a:p>
+          <a:p>
+            <a:r>
+              <a:t>duplicates removed, training, validation and test accuracy are equal, so the model is</a:t>
+            </a:r>
+          </a:p>
+          <a:p>
+            <a:r>
+              <a:t>not overfitting. Our research finding: when routers see very different traffic,</a:t>
+            </a:r>
+          </a:p>
+          <a:p>
+            <a:r>
+              <a:t>per-cluster Mondrian thresholds catch far more poisoned updates than one global</a:t>
+            </a:r>
+          </a:p>
+          <a:p>
+            <a:r>
+              <a:t>threshold, and the second check removes the extra false alarms. Next we would run more</a:t>
+            </a:r>
+          </a:p>
+          <a:p>
+            <a:r>
+              <a:t>seeds on FLNET2023, the 11-class task, use a secret seed for the sketch, and test on a</a:t>
+            </a:r>
+          </a:p>
+          <a:p>
+            <a:r>
+              <a:t>real network. The key references are on the right, and all the code and results are on</a:t>
             </a:r>
           </a:p>
           <a:p>
@@ -1901,12 +2119,7 @@
           </a:p>
           <a:p>
             <a:r>
-              <a:t>flows of each type we have. Most are normal, DoS-hulk and DDoS-tcp; web attacks are</a:t>
-            </a:r>
-          </a:p>
-          <a:p>
-            <a:r>
-              <a:t>rare.</a:t>
+              <a:t>flows of each type we have. Most are DoS-hulk and DDoS-tcp; web attacks are rare.</a:t>
             </a:r>
           </a:p>
           <a:p>
@@ -1926,17 +2139,37 @@
           </a:p>
           <a:p>
             <a:r>
-              <a:t>attacker's address. We remove broken rows and 12 columns that never change. Then a log</a:t>
-            </a:r>
-          </a:p>
-          <a:p>
-            <a:r>
-              <a:t>and a 0 to 1 scaling, fitted only on the training data. The result is 66 features per</a:t>
-            </a:r>
-          </a:p>
-          <a:p>
-            <a:r>
-              <a:t>flow and a label: 0 for normal, 1 for attack.</a:t>
+              <a:t>attacker's address. Then we remove exact duplicate flows: 30 percent of the flows were</a:t>
+            </a:r>
+          </a:p>
+          <a:p>
+            <a:r>
+              <a:t>copies, mostly normal traffic, and a copy in both training and test would let the model</a:t>
+            </a:r>
+          </a:p>
+          <a:p>
+            <a:r>
+              <a:t>pass the test by memory. Next we split each router's flows 70 percent training, 15</a:t>
+            </a:r>
+          </a:p>
+          <a:p>
+            <a:r>
+              <a:t>percent validation and 15 percent test, keeping each router's traffic mix. Validation</a:t>
+            </a:r>
+          </a:p>
+          <a:p>
+            <a:r>
+              <a:t>is used for early stopping and tuning; the test set is used only once, at the end.</a:t>
+            </a:r>
+          </a:p>
+          <a:p>
+            <a:r>
+              <a:t>Last, a log and a 0 to 1 scaling, fitted only on the training part. The result is 66</a:t>
+            </a:r>
+          </a:p>
+          <a:p>
+            <a:r>
+              <a:t>features per flow and a label: 0 for normal, 1 for attack.</a:t>
             </a:r>
           </a:p>
         </p:txBody>
@@ -2011,7 +2244,7 @@
           </a:p>
           <a:p>
             <a:r>
-              <a:t>attack traffic at each of the 10 clients.</a:t>
+              <a:t>attack traffic at each of the 10 clients, in the 70 percent training part.</a:t>
             </a:r>
           </a:p>
           <a:p>
@@ -2021,7 +2254,7 @@
           </a:p>
           <a:p>
             <a:r>
-              <a:t>about 66 percent attack. This is only a control.</a:t>
+              <a:t>about 90 percent attack. This is only a control.</a:t>
             </a:r>
           </a:p>
           <a:p>
@@ -2031,7 +2264,12 @@
           </a:p>
           <a:p>
             <a:r>
-              <a:t>nature: router 3 has 19 percent attacks, router 4 has 92.</a:t>
+              <a:t>nature: router 3 has 44 percent attacks, router 4 has</a:t>
+            </a:r>
+          </a:p>
+          <a:p>
+            <a:r>
+              <a:t>98.</a:t>
             </a:r>
           </a:p>
           <a:p>
@@ -2271,12 +2509,12 @@
           </a:p>
           <a:p>
             <a:r>
-              <a:t>After 15 rounds the federated model reaches 99.93 percent, almost the same as training</a:t>
-            </a:r>
-          </a:p>
-          <a:p>
-            <a:r>
-              <a:t>on all data in one place. In the protected version, steps five to eight happen between</a:t>
+              <a:t>After 15 rounds the federated model reaches 99.96% on the test</a:t>
+            </a:r>
+          </a:p>
+          <a:p>
+            <a:r>
+              <a:t>set, almost the same as training on all data in one place. In the protected version, steps five to eight happen between</a:t>
             </a:r>
           </a:p>
           <a:p>
@@ -10440,7 +10678,7 @@
                 </a:solidFill>
                 <a:latin typeface="Calibri"/>
               </a:rPr>
-              <a:t>Attack: 2 of 10 clients flip labels (attack ↔ normal) from round 6 of 12. Means over 5 (FLNET2023) and 10 (NSL-KDD) seeds.</a:t>
+              <a:t>Attack: 2 of 10 clients flip labels (attack ↔ normal) from round 6 of 12. Krypsis v2 = filter + second check + 15% cap. 5 (FLNET2023) / 10 (NSL-KDD) seeds.</a:t>
             </a:r>
           </a:p>
         </p:txBody>
@@ -10605,7 +10843,7 @@
                 </a:solidFill>
                 <a:latin typeface="Calibri"/>
               </a:rPr>
-              <a:t>99.93%</a:t>
+              <a:t>99.96%</a:t>
             </a:r>
           </a:p>
           <a:p>
@@ -10621,7 +10859,7 @@
                 </a:solidFill>
                 <a:latin typeface="Calibri"/>
               </a:rPr>
-              <a:t>FedAvg accuracy, 10 routers</a:t>
+              <a:t>FedAvg test accuracy, 10 routers</a:t>
             </a:r>
           </a:p>
           <a:p>
@@ -10637,7 +10875,7 @@
                 </a:solidFill>
                 <a:latin typeface="Calibri"/>
               </a:rPr>
-              <a:t>centralized 100.0%</a:t>
+              <a:t>train 99.97% · validation 99.97%</a:t>
             </a:r>
           </a:p>
         </p:txBody>
@@ -10843,7 +11081,7 @@
                 </a:solidFill>
                 <a:latin typeface="Calibri"/>
               </a:rPr>
-              <a:t>71.4% · 99.3%</a:t>
+              <a:t>74.3% · 99.3%</a:t>
             </a:r>
           </a:p>
           <a:p>
@@ -10875,7 +11113,7 @@
                 </a:solidFill>
                 <a:latin typeface="Calibri"/>
               </a:rPr>
-              <a:t>FLNET2023 · NSL-KDD</a:t>
+              <a:t>v2 Mondrian · FLNET2023 · NSL-KDD</a:t>
             </a:r>
           </a:p>
         </p:txBody>
@@ -10962,7 +11200,7 @@
                 </a:solidFill>
                 <a:latin typeface="Calibri"/>
               </a:rPr>
-              <a:t>0.4% · 1.1%</a:t>
+              <a:t>0.7% · 1.8%</a:t>
             </a:r>
           </a:p>
           <a:p>
@@ -10978,7 +11216,7 @@
                 </a:solidFill>
                 <a:latin typeface="Calibri"/>
               </a:rPr>
-              <a:t>honest updates wrongly flagged</a:t>
+              <a:t>honest updates wrongly excluded</a:t>
             </a:r>
           </a:p>
           <a:p>
@@ -10994,7 +11232,7 @@
                 </a:solidFill>
                 <a:latin typeface="Calibri"/>
               </a:rPr>
-              <a:t>FLNET2023 · NSL-KDD</a:t>
+              <a:t>v2 Mondrian · FLNET2023 · NSL-KDD</a:t>
             </a:r>
           </a:p>
         </p:txBody>
@@ -11346,7 +11584,7 @@
         </p:nvSpPr>
         <p:spPr>
           <a:xfrm>
-            <a:off x="3611880" y="1691640"/>
+            <a:off x="3611880" y="1645920"/>
             <a:ext cx="2377440" cy="3383280"/>
           </a:xfrm>
           <a:prstGeom prst="roundRect">
@@ -11394,8 +11632,8 @@
         </p:nvSpPr>
         <p:spPr>
           <a:xfrm>
-            <a:off x="3611880" y="1691640"/>
-            <a:ext cx="2377440" cy="658368"/>
+            <a:off x="3611880" y="1645920"/>
+            <a:ext cx="2377440" cy="548640"/>
           </a:xfrm>
           <a:prstGeom prst="rect">
             <a:avLst/>
@@ -11433,7 +11671,94 @@
         </p:nvSpPr>
         <p:spPr>
           <a:xfrm>
-            <a:off x="6080760" y="1691640"/>
+            <a:off x="6080760" y="1645920"/>
+            <a:ext cx="2377440" cy="3383280"/>
+          </a:xfrm>
+          <a:prstGeom prst="roundRect">
+            <a:avLst>
+              <a:gd name="adj" fmla="val 5000"/>
+            </a:avLst>
+          </a:prstGeom>
+          <a:solidFill>
+            <a:srgbClr val="FFFFFF"/>
+          </a:solidFill>
+          <a:ln w="12700">
+            <a:solidFill>
+              <a:srgbClr val="CFD6CB"/>
+            </a:solidFill>
+          </a:ln>
+          <a:effectLst/>
+        </p:spPr>
+        <p:style>
+          <a:lnRef idx="1">
+            <a:schemeClr val="accent1"/>
+          </a:lnRef>
+          <a:fillRef idx="3">
+            <a:schemeClr val="accent1"/>
+          </a:fillRef>
+          <a:effectRef idx="2">
+            <a:schemeClr val="accent1"/>
+          </a:effectRef>
+          <a:fontRef idx="minor">
+            <a:schemeClr val="lt1"/>
+          </a:fontRef>
+        </p:style>
+        <p:txBody>
+          <a:bodyPr rtlCol="0" anchor="ctr"/>
+          <a:lstStyle/>
+          <a:p>
+            <a:pPr algn="ctr"/>
+          </a:p>
+        </p:txBody>
+      </p:sp>
+      <p:sp>
+        <p:nvSpPr>
+          <p:cNvPr id="12" name="TextBox 11"/>
+          <p:cNvSpPr txBox="1"/>
+          <p:nvPr/>
+        </p:nvSpPr>
+        <p:spPr>
+          <a:xfrm>
+            <a:off x="6080760" y="1645920"/>
+            <a:ext cx="2377440" cy="548640"/>
+          </a:xfrm>
+          <a:prstGeom prst="rect">
+            <a:avLst/>
+          </a:prstGeom>
+          <a:noFill/>
+        </p:spPr>
+        <p:txBody>
+          <a:bodyPr wrap="square" anchor="ctr" lIns="0" rIns="0" tIns="0" bIns="0">
+            <a:spAutoFit/>
+          </a:bodyPr>
+          <a:lstStyle/>
+          <a:p>
+            <a:pPr algn="ctr">
+              <a:lnSpc>
+                <a:spcPct val="115000"/>
+              </a:lnSpc>
+            </a:pPr>
+            <a:r>
+              <a:rPr sz="1400" b="1" i="0">
+                <a:solidFill>
+                  <a:srgbClr val="172420"/>
+                </a:solidFill>
+                <a:latin typeface="Calibri"/>
+              </a:rPr>
+              <a:t>Protocol + global</a:t>
+            </a:r>
+          </a:p>
+        </p:txBody>
+      </p:sp>
+      <p:sp>
+        <p:nvSpPr>
+          <p:cNvPr id="13" name="Rounded Rectangle 12"/>
+          <p:cNvSpPr/>
+          <p:nvPr/>
+        </p:nvSpPr>
+        <p:spPr>
+          <a:xfrm>
+            <a:off x="8549640" y="1645920"/>
             <a:ext cx="2377440" cy="3383280"/>
           </a:xfrm>
           <a:prstGeom prst="roundRect">
@@ -11475,14 +11800,14 @@
       </p:sp>
       <p:sp>
         <p:nvSpPr>
-          <p:cNvPr id="12" name="TextBox 11"/>
+          <p:cNvPr id="14" name="TextBox 13"/>
           <p:cNvSpPr txBox="1"/>
           <p:nvPr/>
         </p:nvSpPr>
         <p:spPr>
           <a:xfrm>
-            <a:off x="6080760" y="1691640"/>
-            <a:ext cx="2377440" cy="658368"/>
+            <a:off x="8549640" y="1645920"/>
+            <a:ext cx="2377440" cy="548640"/>
           </a:xfrm>
           <a:prstGeom prst="rect">
             <a:avLst/>
@@ -11507,20 +11832,20 @@
                 </a:solidFill>
                 <a:latin typeface="Calibri"/>
               </a:rPr>
-              <a:t>Protocol + global</a:t>
-            </a:r>
-          </a:p>
-        </p:txBody>
-      </p:sp>
-      <p:sp>
-        <p:nvSpPr>
-          <p:cNvPr id="13" name="Rounded Rectangle 12"/>
+              <a:t>Protocol + Mondrian</a:t>
+            </a:r>
+          </a:p>
+        </p:txBody>
+      </p:sp>
+      <p:sp>
+        <p:nvSpPr>
+          <p:cNvPr id="15" name="Rounded Rectangle 14"/>
           <p:cNvSpPr/>
           <p:nvPr/>
         </p:nvSpPr>
         <p:spPr>
           <a:xfrm>
-            <a:off x="6858000" y="1536192"/>
+            <a:off x="9326880" y="1490472"/>
             <a:ext cx="822960" cy="274320"/>
           </a:xfrm>
           <a:prstGeom prst="roundRect">
@@ -11560,13 +11885,13 @@
       </p:sp>
       <p:sp>
         <p:nvSpPr>
-          <p:cNvPr id="14" name="TextBox 13"/>
+          <p:cNvPr id="16" name="TextBox 15"/>
           <p:cNvSpPr txBox="1"/>
           <p:nvPr/>
         </p:nvSpPr>
         <p:spPr>
           <a:xfrm>
-            <a:off x="6858000" y="1536192"/>
+            <a:off x="9326880" y="1490472"/>
             <a:ext cx="822960" cy="274320"/>
           </a:xfrm>
           <a:prstGeom prst="rect">
@@ -11597,20 +11922,905 @@
           </a:p>
         </p:txBody>
       </p:sp>
-      <p:sp>
-        <p:nvSpPr>
-          <p:cNvPr id="15" name="Rounded Rectangle 14"/>
+      <p:cxnSp>
+        <p:nvCxnSpPr>
+          <p:cNvPr id="17" name="Connector 16"/>
+          <p:cNvCxnSpPr/>
+          <p:nvPr/>
+        </p:nvCxnSpPr>
+        <p:spPr>
+          <a:xfrm>
+            <a:off x="502920" y="2194560"/>
+            <a:ext cx="10424160" cy="0"/>
+          </a:xfrm>
+          <a:prstGeom prst="line">
+            <a:avLst/>
+          </a:prstGeom>
+          <a:ln w="9525">
+            <a:solidFill>
+              <a:srgbClr val="CFD6CB"/>
+            </a:solidFill>
+          </a:ln>
+        </p:spPr>
+      </p:cxnSp>
+      <p:sp>
+        <p:nvSpPr>
+          <p:cNvPr id="18" name="TextBox 17"/>
+          <p:cNvSpPr txBox="1"/>
+          <p:nvPr/>
+        </p:nvSpPr>
+        <p:spPr>
+          <a:xfrm>
+            <a:off x="502920" y="2194560"/>
+            <a:ext cx="3108960" cy="548640"/>
+          </a:xfrm>
+          <a:prstGeom prst="rect">
+            <a:avLst/>
+          </a:prstGeom>
+          <a:noFill/>
+        </p:spPr>
+        <p:txBody>
+          <a:bodyPr wrap="square" anchor="ctr" lIns="0" rIns="0" tIns="0" bIns="0">
+            <a:spAutoFit/>
+          </a:bodyPr>
+          <a:lstStyle/>
+          <a:p>
+            <a:pPr algn="l">
+              <a:lnSpc>
+                <a:spcPct val="115000"/>
+              </a:lnSpc>
+            </a:pPr>
+            <a:r>
+              <a:rPr sz="1400" b="0" i="0">
+                <a:solidFill>
+                  <a:srgbClr val="56655D"/>
+                </a:solidFill>
+                <a:latin typeface="Calibri"/>
+              </a:rPr>
+              <a:t>Accuracy, rounds 6–12 (mean)</a:t>
+            </a:r>
+          </a:p>
+        </p:txBody>
+      </p:sp>
+      <p:sp>
+        <p:nvSpPr>
+          <p:cNvPr id="19" name="TextBox 18"/>
+          <p:cNvSpPr txBox="1"/>
+          <p:nvPr/>
+        </p:nvSpPr>
+        <p:spPr>
+          <a:xfrm>
+            <a:off x="3611880" y="2194560"/>
+            <a:ext cx="2377440" cy="548640"/>
+          </a:xfrm>
+          <a:prstGeom prst="rect">
+            <a:avLst/>
+          </a:prstGeom>
+          <a:noFill/>
+        </p:spPr>
+        <p:txBody>
+          <a:bodyPr wrap="square" anchor="ctr" lIns="0" rIns="0" tIns="0" bIns="0">
+            <a:spAutoFit/>
+          </a:bodyPr>
+          <a:lstStyle/>
+          <a:p>
+            <a:pPr algn="ctr">
+              <a:lnSpc>
+                <a:spcPct val="115000"/>
+              </a:lnSpc>
+            </a:pPr>
+            <a:r>
+              <a:rPr sz="1700" b="0" i="0">
+                <a:solidFill>
+                  <a:srgbClr val="172420"/>
+                </a:solidFill>
+                <a:latin typeface="Calibri"/>
+              </a:rPr>
+              <a:t>81.9%</a:t>
+            </a:r>
+          </a:p>
+        </p:txBody>
+      </p:sp>
+      <p:sp>
+        <p:nvSpPr>
+          <p:cNvPr id="20" name="TextBox 19"/>
+          <p:cNvSpPr txBox="1"/>
+          <p:nvPr/>
+        </p:nvSpPr>
+        <p:spPr>
+          <a:xfrm>
+            <a:off x="6080760" y="2194560"/>
+            <a:ext cx="2377440" cy="548640"/>
+          </a:xfrm>
+          <a:prstGeom prst="rect">
+            <a:avLst/>
+          </a:prstGeom>
+          <a:noFill/>
+        </p:spPr>
+        <p:txBody>
+          <a:bodyPr wrap="square" anchor="ctr" lIns="0" rIns="0" tIns="0" bIns="0">
+            <a:spAutoFit/>
+          </a:bodyPr>
+          <a:lstStyle/>
+          <a:p>
+            <a:pPr algn="ctr">
+              <a:lnSpc>
+                <a:spcPct val="115000"/>
+              </a:lnSpc>
+            </a:pPr>
+            <a:r>
+              <a:rPr sz="1700" b="0" i="0">
+                <a:solidFill>
+                  <a:srgbClr val="172420"/>
+                </a:solidFill>
+                <a:latin typeface="Calibri"/>
+              </a:rPr>
+              <a:t>85.0%</a:t>
+            </a:r>
+          </a:p>
+        </p:txBody>
+      </p:sp>
+      <p:sp>
+        <p:nvSpPr>
+          <p:cNvPr id="21" name="TextBox 20"/>
+          <p:cNvSpPr txBox="1"/>
+          <p:nvPr/>
+        </p:nvSpPr>
+        <p:spPr>
+          <a:xfrm>
+            <a:off x="8549640" y="2194560"/>
+            <a:ext cx="2377440" cy="548640"/>
+          </a:xfrm>
+          <a:prstGeom prst="rect">
+            <a:avLst/>
+          </a:prstGeom>
+          <a:noFill/>
+        </p:spPr>
+        <p:txBody>
+          <a:bodyPr wrap="square" anchor="ctr" lIns="0" rIns="0" tIns="0" bIns="0">
+            <a:spAutoFit/>
+          </a:bodyPr>
+          <a:lstStyle/>
+          <a:p>
+            <a:pPr algn="ctr">
+              <a:lnSpc>
+                <a:spcPct val="115000"/>
+              </a:lnSpc>
+            </a:pPr>
+            <a:r>
+              <a:rPr sz="1700" b="1" i="0">
+                <a:solidFill>
+                  <a:srgbClr val="146B62"/>
+                </a:solidFill>
+                <a:latin typeface="Calibri"/>
+              </a:rPr>
+              <a:t>94.6%</a:t>
+            </a:r>
+          </a:p>
+        </p:txBody>
+      </p:sp>
+      <p:cxnSp>
+        <p:nvCxnSpPr>
+          <p:cNvPr id="22" name="Connector 21"/>
+          <p:cNvCxnSpPr/>
+          <p:nvPr/>
+        </p:nvCxnSpPr>
+        <p:spPr>
+          <a:xfrm>
+            <a:off x="502920" y="2743200"/>
+            <a:ext cx="10424160" cy="0"/>
+          </a:xfrm>
+          <a:prstGeom prst="line">
+            <a:avLst/>
+          </a:prstGeom>
+          <a:ln w="9525">
+            <a:solidFill>
+              <a:srgbClr val="CFD6CB"/>
+            </a:solidFill>
+          </a:ln>
+        </p:spPr>
+      </p:cxnSp>
+      <p:sp>
+        <p:nvSpPr>
+          <p:cNvPr id="23" name="TextBox 22"/>
+          <p:cNvSpPr txBox="1"/>
+          <p:nvPr/>
+        </p:nvSpPr>
+        <p:spPr>
+          <a:xfrm>
+            <a:off x="502920" y="2743200"/>
+            <a:ext cx="3108960" cy="548640"/>
+          </a:xfrm>
+          <a:prstGeom prst="rect">
+            <a:avLst/>
+          </a:prstGeom>
+          <a:noFill/>
+        </p:spPr>
+        <p:txBody>
+          <a:bodyPr wrap="square" anchor="ctr" lIns="0" rIns="0" tIns="0" bIns="0">
+            <a:spAutoFit/>
+          </a:bodyPr>
+          <a:lstStyle/>
+          <a:p>
+            <a:pPr algn="l">
+              <a:lnSpc>
+                <a:spcPct val="115000"/>
+              </a:lnSpc>
+            </a:pPr>
+            <a:r>
+              <a:rPr sz="1400" b="0" i="0">
+                <a:solidFill>
+                  <a:srgbClr val="56655D"/>
+                </a:solidFill>
+                <a:latin typeface="Calibri"/>
+              </a:rPr>
+              <a:t>Accuracy, last round</a:t>
+            </a:r>
+          </a:p>
+        </p:txBody>
+      </p:sp>
+      <p:sp>
+        <p:nvSpPr>
+          <p:cNvPr id="24" name="TextBox 23"/>
+          <p:cNvSpPr txBox="1"/>
+          <p:nvPr/>
+        </p:nvSpPr>
+        <p:spPr>
+          <a:xfrm>
+            <a:off x="3611880" y="2743200"/>
+            <a:ext cx="2377440" cy="548640"/>
+          </a:xfrm>
+          <a:prstGeom prst="rect">
+            <a:avLst/>
+          </a:prstGeom>
+          <a:noFill/>
+        </p:spPr>
+        <p:txBody>
+          <a:bodyPr wrap="square" anchor="ctr" lIns="0" rIns="0" tIns="0" bIns="0">
+            <a:spAutoFit/>
+          </a:bodyPr>
+          <a:lstStyle/>
+          <a:p>
+            <a:pPr algn="ctr">
+              <a:lnSpc>
+                <a:spcPct val="115000"/>
+              </a:lnSpc>
+            </a:pPr>
+            <a:r>
+              <a:rPr sz="1700" b="0" i="0">
+                <a:solidFill>
+                  <a:srgbClr val="172420"/>
+                </a:solidFill>
+                <a:latin typeface="Calibri"/>
+              </a:rPr>
+              <a:t>76.5%</a:t>
+            </a:r>
+          </a:p>
+        </p:txBody>
+      </p:sp>
+      <p:sp>
+        <p:nvSpPr>
+          <p:cNvPr id="25" name="TextBox 24"/>
+          <p:cNvSpPr txBox="1"/>
+          <p:nvPr/>
+        </p:nvSpPr>
+        <p:spPr>
+          <a:xfrm>
+            <a:off x="6080760" y="2743200"/>
+            <a:ext cx="2377440" cy="548640"/>
+          </a:xfrm>
+          <a:prstGeom prst="rect">
+            <a:avLst/>
+          </a:prstGeom>
+          <a:noFill/>
+        </p:spPr>
+        <p:txBody>
+          <a:bodyPr wrap="square" anchor="ctr" lIns="0" rIns="0" tIns="0" bIns="0">
+            <a:spAutoFit/>
+          </a:bodyPr>
+          <a:lstStyle/>
+          <a:p>
+            <a:pPr algn="ctr">
+              <a:lnSpc>
+                <a:spcPct val="115000"/>
+              </a:lnSpc>
+            </a:pPr>
+            <a:r>
+              <a:rPr sz="1700" b="0" i="0">
+                <a:solidFill>
+                  <a:srgbClr val="172420"/>
+                </a:solidFill>
+                <a:latin typeface="Calibri"/>
+              </a:rPr>
+              <a:t>88.2%</a:t>
+            </a:r>
+          </a:p>
+        </p:txBody>
+      </p:sp>
+      <p:sp>
+        <p:nvSpPr>
+          <p:cNvPr id="26" name="TextBox 25"/>
+          <p:cNvSpPr txBox="1"/>
+          <p:nvPr/>
+        </p:nvSpPr>
+        <p:spPr>
+          <a:xfrm>
+            <a:off x="8549640" y="2743200"/>
+            <a:ext cx="2377440" cy="548640"/>
+          </a:xfrm>
+          <a:prstGeom prst="rect">
+            <a:avLst/>
+          </a:prstGeom>
+          <a:noFill/>
+        </p:spPr>
+        <p:txBody>
+          <a:bodyPr wrap="square" anchor="ctr" lIns="0" rIns="0" tIns="0" bIns="0">
+            <a:spAutoFit/>
+          </a:bodyPr>
+          <a:lstStyle/>
+          <a:p>
+            <a:pPr algn="ctr">
+              <a:lnSpc>
+                <a:spcPct val="115000"/>
+              </a:lnSpc>
+            </a:pPr>
+            <a:r>
+              <a:rPr sz="1700" b="1" i="0">
+                <a:solidFill>
+                  <a:srgbClr val="146B62"/>
+                </a:solidFill>
+                <a:latin typeface="Calibri"/>
+              </a:rPr>
+              <a:t>88.0%</a:t>
+            </a:r>
+          </a:p>
+        </p:txBody>
+      </p:sp>
+      <p:cxnSp>
+        <p:nvCxnSpPr>
+          <p:cNvPr id="27" name="Connector 26"/>
+          <p:cNvCxnSpPr/>
+          <p:nvPr/>
+        </p:nvCxnSpPr>
+        <p:spPr>
+          <a:xfrm>
+            <a:off x="502920" y="3291840"/>
+            <a:ext cx="10424160" cy="0"/>
+          </a:xfrm>
+          <a:prstGeom prst="line">
+            <a:avLst/>
+          </a:prstGeom>
+          <a:ln w="9525">
+            <a:solidFill>
+              <a:srgbClr val="CFD6CB"/>
+            </a:solidFill>
+          </a:ln>
+        </p:spPr>
+      </p:cxnSp>
+      <p:sp>
+        <p:nvSpPr>
+          <p:cNvPr id="28" name="TextBox 27"/>
+          <p:cNvSpPr txBox="1"/>
+          <p:nvPr/>
+        </p:nvSpPr>
+        <p:spPr>
+          <a:xfrm>
+            <a:off x="502920" y="3291840"/>
+            <a:ext cx="3108960" cy="548640"/>
+          </a:xfrm>
+          <a:prstGeom prst="rect">
+            <a:avLst/>
+          </a:prstGeom>
+          <a:noFill/>
+        </p:spPr>
+        <p:txBody>
+          <a:bodyPr wrap="square" anchor="ctr" lIns="0" rIns="0" tIns="0" bIns="0">
+            <a:spAutoFit/>
+          </a:bodyPr>
+          <a:lstStyle/>
+          <a:p>
+            <a:pPr algn="l">
+              <a:lnSpc>
+                <a:spcPct val="115000"/>
+              </a:lnSpc>
+            </a:pPr>
+            <a:r>
+              <a:rPr sz="1400" b="0" i="0">
+                <a:solidFill>
+                  <a:srgbClr val="56655D"/>
+                </a:solidFill>
+                <a:latin typeface="Calibri"/>
+              </a:rPr>
+              <a:t>Attacks caught</a:t>
+            </a:r>
+          </a:p>
+        </p:txBody>
+      </p:sp>
+      <p:sp>
+        <p:nvSpPr>
+          <p:cNvPr id="29" name="TextBox 28"/>
+          <p:cNvSpPr txBox="1"/>
+          <p:nvPr/>
+        </p:nvSpPr>
+        <p:spPr>
+          <a:xfrm>
+            <a:off x="3611880" y="3291840"/>
+            <a:ext cx="2377440" cy="548640"/>
+          </a:xfrm>
+          <a:prstGeom prst="rect">
+            <a:avLst/>
+          </a:prstGeom>
+          <a:noFill/>
+        </p:spPr>
+        <p:txBody>
+          <a:bodyPr wrap="square" anchor="ctr" lIns="0" rIns="0" tIns="0" bIns="0">
+            <a:spAutoFit/>
+          </a:bodyPr>
+          <a:lstStyle/>
+          <a:p>
+            <a:pPr algn="ctr">
+              <a:lnSpc>
+                <a:spcPct val="115000"/>
+              </a:lnSpc>
+            </a:pPr>
+            <a:r>
+              <a:rPr sz="1700" b="0" i="0">
+                <a:solidFill>
+                  <a:srgbClr val="172420"/>
+                </a:solidFill>
+                <a:latin typeface="Calibri"/>
+              </a:rPr>
+              <a:t>—</a:t>
+            </a:r>
+          </a:p>
+        </p:txBody>
+      </p:sp>
+      <p:sp>
+        <p:nvSpPr>
+          <p:cNvPr id="30" name="TextBox 29"/>
+          <p:cNvSpPr txBox="1"/>
+          <p:nvPr/>
+        </p:nvSpPr>
+        <p:spPr>
+          <a:xfrm>
+            <a:off x="6080760" y="3291840"/>
+            <a:ext cx="2377440" cy="548640"/>
+          </a:xfrm>
+          <a:prstGeom prst="rect">
+            <a:avLst/>
+          </a:prstGeom>
+          <a:noFill/>
+        </p:spPr>
+        <p:txBody>
+          <a:bodyPr wrap="square" anchor="ctr" lIns="0" rIns="0" tIns="0" bIns="0">
+            <a:spAutoFit/>
+          </a:bodyPr>
+          <a:lstStyle/>
+          <a:p>
+            <a:pPr algn="ctr">
+              <a:lnSpc>
+                <a:spcPct val="115000"/>
+              </a:lnSpc>
+            </a:pPr>
+            <a:r>
+              <a:rPr sz="1700" b="0" i="0">
+                <a:solidFill>
+                  <a:srgbClr val="172420"/>
+                </a:solidFill>
+                <a:latin typeface="Calibri"/>
+              </a:rPr>
+              <a:t>29.5%</a:t>
+            </a:r>
+          </a:p>
+        </p:txBody>
+      </p:sp>
+      <p:sp>
+        <p:nvSpPr>
+          <p:cNvPr id="31" name="TextBox 30"/>
+          <p:cNvSpPr txBox="1"/>
+          <p:nvPr/>
+        </p:nvSpPr>
+        <p:spPr>
+          <a:xfrm>
+            <a:off x="8549640" y="3291840"/>
+            <a:ext cx="2377440" cy="548640"/>
+          </a:xfrm>
+          <a:prstGeom prst="rect">
+            <a:avLst/>
+          </a:prstGeom>
+          <a:noFill/>
+        </p:spPr>
+        <p:txBody>
+          <a:bodyPr wrap="square" anchor="ctr" lIns="0" rIns="0" tIns="0" bIns="0">
+            <a:spAutoFit/>
+          </a:bodyPr>
+          <a:lstStyle/>
+          <a:p>
+            <a:pPr algn="ctr">
+              <a:lnSpc>
+                <a:spcPct val="115000"/>
+              </a:lnSpc>
+            </a:pPr>
+            <a:r>
+              <a:rPr sz="1700" b="1" i="0">
+                <a:solidFill>
+                  <a:srgbClr val="146B62"/>
+                </a:solidFill>
+                <a:latin typeface="Calibri"/>
+              </a:rPr>
+              <a:t>70.0%</a:t>
+            </a:r>
+          </a:p>
+        </p:txBody>
+      </p:sp>
+      <p:cxnSp>
+        <p:nvCxnSpPr>
+          <p:cNvPr id="32" name="Connector 31"/>
+          <p:cNvCxnSpPr/>
+          <p:nvPr/>
+        </p:nvCxnSpPr>
+        <p:spPr>
+          <a:xfrm>
+            <a:off x="502920" y="3840480"/>
+            <a:ext cx="10424160" cy="0"/>
+          </a:xfrm>
+          <a:prstGeom prst="line">
+            <a:avLst/>
+          </a:prstGeom>
+          <a:ln w="9525">
+            <a:solidFill>
+              <a:srgbClr val="CFD6CB"/>
+            </a:solidFill>
+          </a:ln>
+        </p:spPr>
+      </p:cxnSp>
+      <p:sp>
+        <p:nvSpPr>
+          <p:cNvPr id="33" name="TextBox 32"/>
+          <p:cNvSpPr txBox="1"/>
+          <p:nvPr/>
+        </p:nvSpPr>
+        <p:spPr>
+          <a:xfrm>
+            <a:off x="502920" y="3840480"/>
+            <a:ext cx="3108960" cy="548640"/>
+          </a:xfrm>
+          <a:prstGeom prst="rect">
+            <a:avLst/>
+          </a:prstGeom>
+          <a:noFill/>
+        </p:spPr>
+        <p:txBody>
+          <a:bodyPr wrap="square" anchor="ctr" lIns="0" rIns="0" tIns="0" bIns="0">
+            <a:spAutoFit/>
+          </a:bodyPr>
+          <a:lstStyle/>
+          <a:p>
+            <a:pPr algn="l">
+              <a:lnSpc>
+                <a:spcPct val="115000"/>
+              </a:lnSpc>
+            </a:pPr>
+            <a:r>
+              <a:rPr sz="1400" b="0" i="0">
+                <a:solidFill>
+                  <a:srgbClr val="56655D"/>
+                </a:solidFill>
+                <a:latin typeface="Calibri"/>
+              </a:rPr>
+              <a:t>Honest wrongly flagged</a:t>
+            </a:r>
+          </a:p>
+        </p:txBody>
+      </p:sp>
+      <p:sp>
+        <p:nvSpPr>
+          <p:cNvPr id="34" name="TextBox 33"/>
+          <p:cNvSpPr txBox="1"/>
+          <p:nvPr/>
+        </p:nvSpPr>
+        <p:spPr>
+          <a:xfrm>
+            <a:off x="3611880" y="3840480"/>
+            <a:ext cx="2377440" cy="548640"/>
+          </a:xfrm>
+          <a:prstGeom prst="rect">
+            <a:avLst/>
+          </a:prstGeom>
+          <a:noFill/>
+        </p:spPr>
+        <p:txBody>
+          <a:bodyPr wrap="square" anchor="ctr" lIns="0" rIns="0" tIns="0" bIns="0">
+            <a:spAutoFit/>
+          </a:bodyPr>
+          <a:lstStyle/>
+          <a:p>
+            <a:pPr algn="ctr">
+              <a:lnSpc>
+                <a:spcPct val="115000"/>
+              </a:lnSpc>
+            </a:pPr>
+            <a:r>
+              <a:rPr sz="1700" b="0" i="0">
+                <a:solidFill>
+                  <a:srgbClr val="172420"/>
+                </a:solidFill>
+                <a:latin typeface="Calibri"/>
+              </a:rPr>
+              <a:t>—</a:t>
+            </a:r>
+          </a:p>
+        </p:txBody>
+      </p:sp>
+      <p:sp>
+        <p:nvSpPr>
+          <p:cNvPr id="35" name="TextBox 34"/>
+          <p:cNvSpPr txBox="1"/>
+          <p:nvPr/>
+        </p:nvSpPr>
+        <p:spPr>
+          <a:xfrm>
+            <a:off x="6080760" y="3840480"/>
+            <a:ext cx="2377440" cy="548640"/>
+          </a:xfrm>
+          <a:prstGeom prst="rect">
+            <a:avLst/>
+          </a:prstGeom>
+          <a:noFill/>
+        </p:spPr>
+        <p:txBody>
+          <a:bodyPr wrap="square" anchor="ctr" lIns="0" rIns="0" tIns="0" bIns="0">
+            <a:spAutoFit/>
+          </a:bodyPr>
+          <a:lstStyle/>
+          <a:p>
+            <a:pPr algn="ctr">
+              <a:lnSpc>
+                <a:spcPct val="115000"/>
+              </a:lnSpc>
+            </a:pPr>
+            <a:r>
+              <a:rPr sz="1700" b="0" i="0">
+                <a:solidFill>
+                  <a:srgbClr val="172420"/>
+                </a:solidFill>
+                <a:latin typeface="Calibri"/>
+              </a:rPr>
+              <a:t>2.0%</a:t>
+            </a:r>
+          </a:p>
+        </p:txBody>
+      </p:sp>
+      <p:sp>
+        <p:nvSpPr>
+          <p:cNvPr id="36" name="TextBox 35"/>
+          <p:cNvSpPr txBox="1"/>
+          <p:nvPr/>
+        </p:nvSpPr>
+        <p:spPr>
+          <a:xfrm>
+            <a:off x="8549640" y="3840480"/>
+            <a:ext cx="2377440" cy="548640"/>
+          </a:xfrm>
+          <a:prstGeom prst="rect">
+            <a:avLst/>
+          </a:prstGeom>
+          <a:noFill/>
+        </p:spPr>
+        <p:txBody>
+          <a:bodyPr wrap="square" anchor="ctr" lIns="0" rIns="0" tIns="0" bIns="0">
+            <a:spAutoFit/>
+          </a:bodyPr>
+          <a:lstStyle/>
+          <a:p>
+            <a:pPr algn="ctr">
+              <a:lnSpc>
+                <a:spcPct val="115000"/>
+              </a:lnSpc>
+            </a:pPr>
+            <a:r>
+              <a:rPr sz="1700" b="1" i="0">
+                <a:solidFill>
+                  <a:srgbClr val="146B62"/>
+                </a:solidFill>
+                <a:latin typeface="Calibri"/>
+              </a:rPr>
+              <a:t>12.9%</a:t>
+            </a:r>
+          </a:p>
+        </p:txBody>
+      </p:sp>
+      <p:cxnSp>
+        <p:nvCxnSpPr>
+          <p:cNvPr id="37" name="Connector 36"/>
+          <p:cNvCxnSpPr/>
+          <p:nvPr/>
+        </p:nvCxnSpPr>
+        <p:spPr>
+          <a:xfrm>
+            <a:off x="502920" y="4389120"/>
+            <a:ext cx="10424160" cy="0"/>
+          </a:xfrm>
+          <a:prstGeom prst="line">
+            <a:avLst/>
+          </a:prstGeom>
+          <a:ln w="9525">
+            <a:solidFill>
+              <a:srgbClr val="CFD6CB"/>
+            </a:solidFill>
+          </a:ln>
+        </p:spPr>
+      </p:cxnSp>
+      <p:sp>
+        <p:nvSpPr>
+          <p:cNvPr id="38" name="TextBox 37"/>
+          <p:cNvSpPr txBox="1"/>
+          <p:nvPr/>
+        </p:nvSpPr>
+        <p:spPr>
+          <a:xfrm>
+            <a:off x="502920" y="4389120"/>
+            <a:ext cx="3108960" cy="548640"/>
+          </a:xfrm>
+          <a:prstGeom prst="rect">
+            <a:avLst/>
+          </a:prstGeom>
+          <a:noFill/>
+        </p:spPr>
+        <p:txBody>
+          <a:bodyPr wrap="square" anchor="ctr" lIns="0" rIns="0" tIns="0" bIns="0">
+            <a:spAutoFit/>
+          </a:bodyPr>
+          <a:lstStyle/>
+          <a:p>
+            <a:pPr algn="l">
+              <a:lnSpc>
+                <a:spcPct val="115000"/>
+              </a:lnSpc>
+            </a:pPr>
+            <a:r>
+              <a:rPr sz="1400" b="0" i="0">
+                <a:solidFill>
+                  <a:srgbClr val="56655D"/>
+                </a:solidFill>
+                <a:latin typeface="Calibri"/>
+              </a:rPr>
+              <a:t>Tampered rejected</a:t>
+            </a:r>
+          </a:p>
+        </p:txBody>
+      </p:sp>
+      <p:sp>
+        <p:nvSpPr>
+          <p:cNvPr id="39" name="TextBox 38"/>
+          <p:cNvSpPr txBox="1"/>
+          <p:nvPr/>
+        </p:nvSpPr>
+        <p:spPr>
+          <a:xfrm>
+            <a:off x="3611880" y="4389120"/>
+            <a:ext cx="2377440" cy="548640"/>
+          </a:xfrm>
+          <a:prstGeom prst="rect">
+            <a:avLst/>
+          </a:prstGeom>
+          <a:noFill/>
+        </p:spPr>
+        <p:txBody>
+          <a:bodyPr wrap="square" anchor="ctr" lIns="0" rIns="0" tIns="0" bIns="0">
+            <a:spAutoFit/>
+          </a:bodyPr>
+          <a:lstStyle/>
+          <a:p>
+            <a:pPr algn="ctr">
+              <a:lnSpc>
+                <a:spcPct val="115000"/>
+              </a:lnSpc>
+            </a:pPr>
+            <a:r>
+              <a:rPr sz="1700" b="0" i="0">
+                <a:solidFill>
+                  <a:srgbClr val="172420"/>
+                </a:solidFill>
+                <a:latin typeface="Calibri"/>
+              </a:rPr>
+              <a:t>not checked</a:t>
+            </a:r>
+          </a:p>
+        </p:txBody>
+      </p:sp>
+      <p:sp>
+        <p:nvSpPr>
+          <p:cNvPr id="40" name="TextBox 39"/>
+          <p:cNvSpPr txBox="1"/>
+          <p:nvPr/>
+        </p:nvSpPr>
+        <p:spPr>
+          <a:xfrm>
+            <a:off x="6080760" y="4389120"/>
+            <a:ext cx="2377440" cy="548640"/>
+          </a:xfrm>
+          <a:prstGeom prst="rect">
+            <a:avLst/>
+          </a:prstGeom>
+          <a:noFill/>
+        </p:spPr>
+        <p:txBody>
+          <a:bodyPr wrap="square" anchor="ctr" lIns="0" rIns="0" tIns="0" bIns="0">
+            <a:spAutoFit/>
+          </a:bodyPr>
+          <a:lstStyle/>
+          <a:p>
+            <a:pPr algn="ctr">
+              <a:lnSpc>
+                <a:spcPct val="115000"/>
+              </a:lnSpc>
+            </a:pPr>
+            <a:r>
+              <a:rPr sz="1700" b="0" i="0">
+                <a:solidFill>
+                  <a:srgbClr val="172420"/>
+                </a:solidFill>
+                <a:latin typeface="Calibri"/>
+              </a:rPr>
+              <a:t>105 / 105</a:t>
+            </a:r>
+          </a:p>
+        </p:txBody>
+      </p:sp>
+      <p:sp>
+        <p:nvSpPr>
+          <p:cNvPr id="41" name="TextBox 40"/>
+          <p:cNvSpPr txBox="1"/>
+          <p:nvPr/>
+        </p:nvSpPr>
+        <p:spPr>
+          <a:xfrm>
+            <a:off x="8549640" y="4389120"/>
+            <a:ext cx="2377440" cy="548640"/>
+          </a:xfrm>
+          <a:prstGeom prst="rect">
+            <a:avLst/>
+          </a:prstGeom>
+          <a:noFill/>
+        </p:spPr>
+        <p:txBody>
+          <a:bodyPr wrap="square" anchor="ctr" lIns="0" rIns="0" tIns="0" bIns="0">
+            <a:spAutoFit/>
+          </a:bodyPr>
+          <a:lstStyle/>
+          <a:p>
+            <a:pPr algn="ctr">
+              <a:lnSpc>
+                <a:spcPct val="115000"/>
+              </a:lnSpc>
+            </a:pPr>
+            <a:r>
+              <a:rPr sz="1700" b="1" i="0">
+                <a:solidFill>
+                  <a:srgbClr val="146B62"/>
+                </a:solidFill>
+                <a:latin typeface="Calibri"/>
+              </a:rPr>
+              <a:t>105 / 105</a:t>
+            </a:r>
+          </a:p>
+        </p:txBody>
+      </p:sp>
+      <p:sp>
+        <p:nvSpPr>
+          <p:cNvPr id="42" name="Rounded Rectangle 41"/>
           <p:cNvSpPr/>
           <p:nvPr/>
         </p:nvSpPr>
         <p:spPr>
           <a:xfrm>
-            <a:off x="8549640" y="1691640"/>
-            <a:ext cx="2377440" cy="3383280"/>
+            <a:off x="502920" y="5257800"/>
+            <a:ext cx="11183112" cy="914400"/>
           </a:xfrm>
           <a:prstGeom prst="roundRect">
             <a:avLst>
-              <a:gd name="adj" fmla="val 5000"/>
+              <a:gd name="adj" fmla="val 8000"/>
             </a:avLst>
           </a:prstGeom>
           <a:solidFill>
@@ -11647,774 +12857,23 @@
       </p:sp>
       <p:sp>
         <p:nvSpPr>
-          <p:cNvPr id="16" name="TextBox 15"/>
-          <p:cNvSpPr txBox="1"/>
-          <p:nvPr/>
-        </p:nvSpPr>
-        <p:spPr>
-          <a:xfrm>
-            <a:off x="8549640" y="1691640"/>
-            <a:ext cx="2377440" cy="658368"/>
-          </a:xfrm>
-          <a:prstGeom prst="rect">
-            <a:avLst/>
-          </a:prstGeom>
-          <a:noFill/>
-        </p:spPr>
-        <p:txBody>
-          <a:bodyPr wrap="square" anchor="ctr" lIns="0" rIns="0" tIns="0" bIns="0">
-            <a:spAutoFit/>
-          </a:bodyPr>
-          <a:lstStyle/>
-          <a:p>
-            <a:pPr algn="ctr">
-              <a:lnSpc>
-                <a:spcPct val="115000"/>
-              </a:lnSpc>
-            </a:pPr>
-            <a:r>
-              <a:rPr sz="1400" b="1" i="0">
-                <a:solidFill>
-                  <a:srgbClr val="172420"/>
-                </a:solidFill>
-                <a:latin typeface="Calibri"/>
-              </a:rPr>
-              <a:t>Protocol + Mondrian</a:t>
-            </a:r>
-          </a:p>
-        </p:txBody>
-      </p:sp>
-      <p:cxnSp>
-        <p:nvCxnSpPr>
-          <p:cNvPr id="17" name="Connector 16"/>
-          <p:cNvCxnSpPr/>
-          <p:nvPr/>
-        </p:nvCxnSpPr>
-        <p:spPr>
-          <a:xfrm>
-            <a:off x="502920" y="2350008"/>
-            <a:ext cx="10424160" cy="0"/>
-          </a:xfrm>
-          <a:prstGeom prst="line">
-            <a:avLst/>
-          </a:prstGeom>
-          <a:ln w="9525">
-            <a:solidFill>
-              <a:srgbClr val="CFD6CB"/>
-            </a:solidFill>
-          </a:ln>
-        </p:spPr>
-      </p:cxnSp>
-      <p:sp>
-        <p:nvSpPr>
-          <p:cNvPr id="18" name="TextBox 17"/>
-          <p:cNvSpPr txBox="1"/>
-          <p:nvPr/>
-        </p:nvSpPr>
-        <p:spPr>
-          <a:xfrm>
-            <a:off x="502920" y="2350008"/>
-            <a:ext cx="3108960" cy="658368"/>
-          </a:xfrm>
-          <a:prstGeom prst="rect">
-            <a:avLst/>
-          </a:prstGeom>
-          <a:noFill/>
-        </p:spPr>
-        <p:txBody>
-          <a:bodyPr wrap="square" anchor="ctr" lIns="0" rIns="0" tIns="0" bIns="0">
-            <a:spAutoFit/>
-          </a:bodyPr>
-          <a:lstStyle/>
-          <a:p>
-            <a:pPr algn="l">
-              <a:lnSpc>
-                <a:spcPct val="115000"/>
-              </a:lnSpc>
-            </a:pPr>
-            <a:r>
-              <a:rPr sz="1400" b="0" i="0">
-                <a:solidFill>
-                  <a:srgbClr val="56655D"/>
-                </a:solidFill>
-                <a:latin typeface="Calibri"/>
-              </a:rPr>
-              <a:t>Accuracy under attack</a:t>
-            </a:r>
-          </a:p>
-        </p:txBody>
-      </p:sp>
-      <p:sp>
-        <p:nvSpPr>
-          <p:cNvPr id="19" name="TextBox 18"/>
-          <p:cNvSpPr txBox="1"/>
-          <p:nvPr/>
-        </p:nvSpPr>
-        <p:spPr>
-          <a:xfrm>
-            <a:off x="3611880" y="2350008"/>
-            <a:ext cx="2377440" cy="658368"/>
-          </a:xfrm>
-          <a:prstGeom prst="rect">
-            <a:avLst/>
-          </a:prstGeom>
-          <a:noFill/>
-        </p:spPr>
-        <p:txBody>
-          <a:bodyPr wrap="square" anchor="ctr" lIns="0" rIns="0" tIns="0" bIns="0">
-            <a:spAutoFit/>
-          </a:bodyPr>
-          <a:lstStyle/>
-          <a:p>
-            <a:pPr algn="ctr">
-              <a:lnSpc>
-                <a:spcPct val="115000"/>
-              </a:lnSpc>
-            </a:pPr>
-            <a:r>
-              <a:rPr sz="1700" b="0" i="0">
-                <a:solidFill>
-                  <a:srgbClr val="172420"/>
-                </a:solidFill>
-                <a:latin typeface="Calibri"/>
-              </a:rPr>
-              <a:t>78.0%</a:t>
-            </a:r>
-          </a:p>
-        </p:txBody>
-      </p:sp>
-      <p:sp>
-        <p:nvSpPr>
-          <p:cNvPr id="20" name="TextBox 19"/>
-          <p:cNvSpPr txBox="1"/>
-          <p:nvPr/>
-        </p:nvSpPr>
-        <p:spPr>
-          <a:xfrm>
-            <a:off x="6080760" y="2350008"/>
-            <a:ext cx="2377440" cy="658368"/>
-          </a:xfrm>
-          <a:prstGeom prst="rect">
-            <a:avLst/>
-          </a:prstGeom>
-          <a:noFill/>
-        </p:spPr>
-        <p:txBody>
-          <a:bodyPr wrap="square" anchor="ctr" lIns="0" rIns="0" tIns="0" bIns="0">
-            <a:spAutoFit/>
-          </a:bodyPr>
-          <a:lstStyle/>
-          <a:p>
-            <a:pPr algn="ctr">
-              <a:lnSpc>
-                <a:spcPct val="115000"/>
-              </a:lnSpc>
-            </a:pPr>
-            <a:r>
-              <a:rPr sz="1700" b="1" i="0">
-                <a:solidFill>
-                  <a:srgbClr val="146B62"/>
-                </a:solidFill>
-                <a:latin typeface="Calibri"/>
-              </a:rPr>
-              <a:t>88.2%</a:t>
-            </a:r>
-          </a:p>
-        </p:txBody>
-      </p:sp>
-      <p:sp>
-        <p:nvSpPr>
-          <p:cNvPr id="21" name="TextBox 20"/>
-          <p:cNvSpPr txBox="1"/>
-          <p:nvPr/>
-        </p:nvSpPr>
-        <p:spPr>
-          <a:xfrm>
-            <a:off x="8549640" y="2350008"/>
-            <a:ext cx="2377440" cy="658368"/>
-          </a:xfrm>
-          <a:prstGeom prst="rect">
-            <a:avLst/>
-          </a:prstGeom>
-          <a:noFill/>
-        </p:spPr>
-        <p:txBody>
-          <a:bodyPr wrap="square" anchor="ctr" lIns="0" rIns="0" tIns="0" bIns="0">
-            <a:spAutoFit/>
-          </a:bodyPr>
-          <a:lstStyle/>
-          <a:p>
-            <a:pPr algn="ctr">
-              <a:lnSpc>
-                <a:spcPct val="115000"/>
-              </a:lnSpc>
-            </a:pPr>
-            <a:r>
-              <a:rPr sz="1700" b="0" i="0">
-                <a:solidFill>
-                  <a:srgbClr val="172420"/>
-                </a:solidFill>
-                <a:latin typeface="Calibri"/>
-              </a:rPr>
-              <a:t>87.5%</a:t>
-            </a:r>
-          </a:p>
-        </p:txBody>
-      </p:sp>
-      <p:cxnSp>
-        <p:nvCxnSpPr>
-          <p:cNvPr id="22" name="Connector 21"/>
-          <p:cNvCxnSpPr/>
-          <p:nvPr/>
-        </p:nvCxnSpPr>
-        <p:spPr>
-          <a:xfrm>
-            <a:off x="502920" y="3008376"/>
-            <a:ext cx="10424160" cy="0"/>
-          </a:xfrm>
-          <a:prstGeom prst="line">
-            <a:avLst/>
-          </a:prstGeom>
-          <a:ln w="9525">
-            <a:solidFill>
-              <a:srgbClr val="CFD6CB"/>
-            </a:solidFill>
-          </a:ln>
-        </p:spPr>
-      </p:cxnSp>
-      <p:sp>
-        <p:nvSpPr>
-          <p:cNvPr id="23" name="TextBox 22"/>
-          <p:cNvSpPr txBox="1"/>
-          <p:nvPr/>
-        </p:nvSpPr>
-        <p:spPr>
-          <a:xfrm>
-            <a:off x="502920" y="3008376"/>
-            <a:ext cx="3108960" cy="658368"/>
-          </a:xfrm>
-          <a:prstGeom prst="rect">
-            <a:avLst/>
-          </a:prstGeom>
-          <a:noFill/>
-        </p:spPr>
-        <p:txBody>
-          <a:bodyPr wrap="square" anchor="ctr" lIns="0" rIns="0" tIns="0" bIns="0">
-            <a:spAutoFit/>
-          </a:bodyPr>
-          <a:lstStyle/>
-          <a:p>
-            <a:pPr algn="l">
-              <a:lnSpc>
-                <a:spcPct val="115000"/>
-              </a:lnSpc>
-            </a:pPr>
-            <a:r>
-              <a:rPr sz="1400" b="0" i="0">
-                <a:solidFill>
-                  <a:srgbClr val="56655D"/>
-                </a:solidFill>
-                <a:latin typeface="Calibri"/>
-              </a:rPr>
-              <a:t>Attacks caught</a:t>
-            </a:r>
-          </a:p>
-        </p:txBody>
-      </p:sp>
-      <p:sp>
-        <p:nvSpPr>
-          <p:cNvPr id="24" name="TextBox 23"/>
-          <p:cNvSpPr txBox="1"/>
-          <p:nvPr/>
-        </p:nvSpPr>
-        <p:spPr>
-          <a:xfrm>
-            <a:off x="3611880" y="3008376"/>
-            <a:ext cx="2377440" cy="658368"/>
-          </a:xfrm>
-          <a:prstGeom prst="rect">
-            <a:avLst/>
-          </a:prstGeom>
-          <a:noFill/>
-        </p:spPr>
-        <p:txBody>
-          <a:bodyPr wrap="square" anchor="ctr" lIns="0" rIns="0" tIns="0" bIns="0">
-            <a:spAutoFit/>
-          </a:bodyPr>
-          <a:lstStyle/>
-          <a:p>
-            <a:pPr algn="ctr">
-              <a:lnSpc>
-                <a:spcPct val="115000"/>
-              </a:lnSpc>
-            </a:pPr>
-            <a:r>
-              <a:rPr sz="1700" b="0" i="0">
-                <a:solidFill>
-                  <a:srgbClr val="172420"/>
-                </a:solidFill>
-                <a:latin typeface="Calibri"/>
-              </a:rPr>
-              <a:t>—</a:t>
-            </a:r>
-          </a:p>
-        </p:txBody>
-      </p:sp>
-      <p:sp>
-        <p:nvSpPr>
-          <p:cNvPr id="25" name="TextBox 24"/>
-          <p:cNvSpPr txBox="1"/>
-          <p:nvPr/>
-        </p:nvSpPr>
-        <p:spPr>
-          <a:xfrm>
-            <a:off x="6080760" y="3008376"/>
-            <a:ext cx="2377440" cy="658368"/>
-          </a:xfrm>
-          <a:prstGeom prst="rect">
-            <a:avLst/>
-          </a:prstGeom>
-          <a:noFill/>
-        </p:spPr>
-        <p:txBody>
-          <a:bodyPr wrap="square" anchor="ctr" lIns="0" rIns="0" tIns="0" bIns="0">
-            <a:spAutoFit/>
-          </a:bodyPr>
-          <a:lstStyle/>
-          <a:p>
-            <a:pPr algn="ctr">
-              <a:lnSpc>
-                <a:spcPct val="115000"/>
-              </a:lnSpc>
-            </a:pPr>
-            <a:r>
-              <a:rPr sz="1700" b="1" i="0">
-                <a:solidFill>
-                  <a:srgbClr val="146B62"/>
-                </a:solidFill>
-                <a:latin typeface="Calibri"/>
-              </a:rPr>
-              <a:t>53.3%</a:t>
-            </a:r>
-          </a:p>
-        </p:txBody>
-      </p:sp>
-      <p:sp>
-        <p:nvSpPr>
-          <p:cNvPr id="26" name="TextBox 25"/>
-          <p:cNvSpPr txBox="1"/>
-          <p:nvPr/>
-        </p:nvSpPr>
-        <p:spPr>
-          <a:xfrm>
-            <a:off x="8549640" y="3008376"/>
-            <a:ext cx="2377440" cy="658368"/>
-          </a:xfrm>
-          <a:prstGeom prst="rect">
-            <a:avLst/>
-          </a:prstGeom>
-          <a:noFill/>
-        </p:spPr>
-        <p:txBody>
-          <a:bodyPr wrap="square" anchor="ctr" lIns="0" rIns="0" tIns="0" bIns="0">
-            <a:spAutoFit/>
-          </a:bodyPr>
-          <a:lstStyle/>
-          <a:p>
-            <a:pPr algn="ctr">
-              <a:lnSpc>
-                <a:spcPct val="115000"/>
-              </a:lnSpc>
-            </a:pPr>
-            <a:r>
-              <a:rPr sz="1700" b="0" i="0">
-                <a:solidFill>
-                  <a:srgbClr val="172420"/>
-                </a:solidFill>
-                <a:latin typeface="Calibri"/>
-              </a:rPr>
-              <a:t>57.6%</a:t>
-            </a:r>
-          </a:p>
-        </p:txBody>
-      </p:sp>
-      <p:cxnSp>
-        <p:nvCxnSpPr>
-          <p:cNvPr id="27" name="Connector 26"/>
-          <p:cNvCxnSpPr/>
-          <p:nvPr/>
-        </p:nvCxnSpPr>
-        <p:spPr>
-          <a:xfrm>
-            <a:off x="502920" y="3666744"/>
-            <a:ext cx="10424160" cy="0"/>
-          </a:xfrm>
-          <a:prstGeom prst="line">
-            <a:avLst/>
-          </a:prstGeom>
-          <a:ln w="9525">
-            <a:solidFill>
-              <a:srgbClr val="CFD6CB"/>
-            </a:solidFill>
-          </a:ln>
-        </p:spPr>
-      </p:cxnSp>
-      <p:sp>
-        <p:nvSpPr>
-          <p:cNvPr id="28" name="TextBox 27"/>
-          <p:cNvSpPr txBox="1"/>
-          <p:nvPr/>
-        </p:nvSpPr>
-        <p:spPr>
-          <a:xfrm>
-            <a:off x="502920" y="3666744"/>
-            <a:ext cx="3108960" cy="658368"/>
-          </a:xfrm>
-          <a:prstGeom prst="rect">
-            <a:avLst/>
-          </a:prstGeom>
-          <a:noFill/>
-        </p:spPr>
-        <p:txBody>
-          <a:bodyPr wrap="square" anchor="ctr" lIns="0" rIns="0" tIns="0" bIns="0">
-            <a:spAutoFit/>
-          </a:bodyPr>
-          <a:lstStyle/>
-          <a:p>
-            <a:pPr algn="l">
-              <a:lnSpc>
-                <a:spcPct val="115000"/>
-              </a:lnSpc>
-            </a:pPr>
-            <a:r>
-              <a:rPr sz="1400" b="0" i="0">
-                <a:solidFill>
-                  <a:srgbClr val="56655D"/>
-                </a:solidFill>
-                <a:latin typeface="Calibri"/>
-              </a:rPr>
-              <a:t>Honest wrongly flagged</a:t>
-            </a:r>
-          </a:p>
-        </p:txBody>
-      </p:sp>
-      <p:sp>
-        <p:nvSpPr>
-          <p:cNvPr id="29" name="TextBox 28"/>
-          <p:cNvSpPr txBox="1"/>
-          <p:nvPr/>
-        </p:nvSpPr>
-        <p:spPr>
-          <a:xfrm>
-            <a:off x="3611880" y="3666744"/>
-            <a:ext cx="2377440" cy="658368"/>
-          </a:xfrm>
-          <a:prstGeom prst="rect">
-            <a:avLst/>
-          </a:prstGeom>
-          <a:noFill/>
-        </p:spPr>
-        <p:txBody>
-          <a:bodyPr wrap="square" anchor="ctr" lIns="0" rIns="0" tIns="0" bIns="0">
-            <a:spAutoFit/>
-          </a:bodyPr>
-          <a:lstStyle/>
-          <a:p>
-            <a:pPr algn="ctr">
-              <a:lnSpc>
-                <a:spcPct val="115000"/>
-              </a:lnSpc>
-            </a:pPr>
-            <a:r>
-              <a:rPr sz="1700" b="0" i="0">
-                <a:solidFill>
-                  <a:srgbClr val="172420"/>
-                </a:solidFill>
-                <a:latin typeface="Calibri"/>
-              </a:rPr>
-              <a:t>—</a:t>
-            </a:r>
-          </a:p>
-        </p:txBody>
-      </p:sp>
-      <p:sp>
-        <p:nvSpPr>
-          <p:cNvPr id="30" name="TextBox 29"/>
-          <p:cNvSpPr txBox="1"/>
-          <p:nvPr/>
-        </p:nvSpPr>
-        <p:spPr>
-          <a:xfrm>
-            <a:off x="6080760" y="3666744"/>
-            <a:ext cx="2377440" cy="658368"/>
-          </a:xfrm>
-          <a:prstGeom prst="rect">
-            <a:avLst/>
-          </a:prstGeom>
-          <a:noFill/>
-        </p:spPr>
-        <p:txBody>
-          <a:bodyPr wrap="square" anchor="ctr" lIns="0" rIns="0" tIns="0" bIns="0">
-            <a:spAutoFit/>
-          </a:bodyPr>
-          <a:lstStyle/>
-          <a:p>
-            <a:pPr algn="ctr">
-              <a:lnSpc>
-                <a:spcPct val="115000"/>
-              </a:lnSpc>
-            </a:pPr>
-            <a:r>
-              <a:rPr sz="1700" b="1" i="0">
-                <a:solidFill>
-                  <a:srgbClr val="146B62"/>
-                </a:solidFill>
-                <a:latin typeface="Calibri"/>
-              </a:rPr>
-              <a:t>2.7%</a:t>
-            </a:r>
-          </a:p>
-        </p:txBody>
-      </p:sp>
-      <p:sp>
-        <p:nvSpPr>
-          <p:cNvPr id="31" name="TextBox 30"/>
-          <p:cNvSpPr txBox="1"/>
-          <p:nvPr/>
-        </p:nvSpPr>
-        <p:spPr>
-          <a:xfrm>
-            <a:off x="8549640" y="3666744"/>
-            <a:ext cx="2377440" cy="658368"/>
-          </a:xfrm>
-          <a:prstGeom prst="rect">
-            <a:avLst/>
-          </a:prstGeom>
-          <a:noFill/>
-        </p:spPr>
-        <p:txBody>
-          <a:bodyPr wrap="square" anchor="ctr" lIns="0" rIns="0" tIns="0" bIns="0">
-            <a:spAutoFit/>
-          </a:bodyPr>
-          <a:lstStyle/>
-          <a:p>
-            <a:pPr algn="ctr">
-              <a:lnSpc>
-                <a:spcPct val="115000"/>
-              </a:lnSpc>
-            </a:pPr>
-            <a:r>
-              <a:rPr sz="1700" b="0" i="0">
-                <a:solidFill>
-                  <a:srgbClr val="172420"/>
-                </a:solidFill>
-                <a:latin typeface="Calibri"/>
-              </a:rPr>
-              <a:t>4.6%</a:t>
-            </a:r>
-          </a:p>
-        </p:txBody>
-      </p:sp>
-      <p:cxnSp>
-        <p:nvCxnSpPr>
-          <p:cNvPr id="32" name="Connector 31"/>
-          <p:cNvCxnSpPr/>
-          <p:nvPr/>
-        </p:nvCxnSpPr>
-        <p:spPr>
-          <a:xfrm>
-            <a:off x="502920" y="4325112"/>
-            <a:ext cx="10424160" cy="0"/>
-          </a:xfrm>
-          <a:prstGeom prst="line">
-            <a:avLst/>
-          </a:prstGeom>
-          <a:ln w="9525">
-            <a:solidFill>
-              <a:srgbClr val="CFD6CB"/>
-            </a:solidFill>
-          </a:ln>
-        </p:spPr>
-      </p:cxnSp>
-      <p:sp>
-        <p:nvSpPr>
-          <p:cNvPr id="33" name="TextBox 32"/>
-          <p:cNvSpPr txBox="1"/>
-          <p:nvPr/>
-        </p:nvSpPr>
-        <p:spPr>
-          <a:xfrm>
-            <a:off x="502920" y="4325112"/>
-            <a:ext cx="3108960" cy="658368"/>
-          </a:xfrm>
-          <a:prstGeom prst="rect">
-            <a:avLst/>
-          </a:prstGeom>
-          <a:noFill/>
-        </p:spPr>
-        <p:txBody>
-          <a:bodyPr wrap="square" anchor="ctr" lIns="0" rIns="0" tIns="0" bIns="0">
-            <a:spAutoFit/>
-          </a:bodyPr>
-          <a:lstStyle/>
-          <a:p>
-            <a:pPr algn="l">
-              <a:lnSpc>
-                <a:spcPct val="115000"/>
-              </a:lnSpc>
-            </a:pPr>
-            <a:r>
-              <a:rPr sz="1400" b="0" i="0">
-                <a:solidFill>
-                  <a:srgbClr val="56655D"/>
-                </a:solidFill>
-                <a:latin typeface="Calibri"/>
-              </a:rPr>
-              <a:t>Tampered rejected</a:t>
-            </a:r>
-          </a:p>
-        </p:txBody>
-      </p:sp>
-      <p:sp>
-        <p:nvSpPr>
-          <p:cNvPr id="34" name="TextBox 33"/>
-          <p:cNvSpPr txBox="1"/>
-          <p:nvPr/>
-        </p:nvSpPr>
-        <p:spPr>
-          <a:xfrm>
-            <a:off x="3611880" y="4325112"/>
-            <a:ext cx="2377440" cy="658368"/>
-          </a:xfrm>
-          <a:prstGeom prst="rect">
-            <a:avLst/>
-          </a:prstGeom>
-          <a:noFill/>
-        </p:spPr>
-        <p:txBody>
-          <a:bodyPr wrap="square" anchor="ctr" lIns="0" rIns="0" tIns="0" bIns="0">
-            <a:spAutoFit/>
-          </a:bodyPr>
-          <a:lstStyle/>
-          <a:p>
-            <a:pPr algn="ctr">
-              <a:lnSpc>
-                <a:spcPct val="115000"/>
-              </a:lnSpc>
-            </a:pPr>
-            <a:r>
-              <a:rPr sz="1700" b="0" i="0">
-                <a:solidFill>
-                  <a:srgbClr val="172420"/>
-                </a:solidFill>
-                <a:latin typeface="Calibri"/>
-              </a:rPr>
-              <a:t>not checked</a:t>
-            </a:r>
-          </a:p>
-        </p:txBody>
-      </p:sp>
-      <p:sp>
-        <p:nvSpPr>
-          <p:cNvPr id="35" name="TextBox 34"/>
-          <p:cNvSpPr txBox="1"/>
-          <p:nvPr/>
-        </p:nvSpPr>
-        <p:spPr>
-          <a:xfrm>
-            <a:off x="6080760" y="4325112"/>
-            <a:ext cx="2377440" cy="658368"/>
-          </a:xfrm>
-          <a:prstGeom prst="rect">
-            <a:avLst/>
-          </a:prstGeom>
-          <a:noFill/>
-        </p:spPr>
-        <p:txBody>
-          <a:bodyPr wrap="square" anchor="ctr" lIns="0" rIns="0" tIns="0" bIns="0">
-            <a:spAutoFit/>
-          </a:bodyPr>
-          <a:lstStyle/>
-          <a:p>
-            <a:pPr algn="ctr">
-              <a:lnSpc>
-                <a:spcPct val="115000"/>
-              </a:lnSpc>
-            </a:pPr>
-            <a:r>
-              <a:rPr sz="1700" b="1" i="0">
-                <a:solidFill>
-                  <a:srgbClr val="146B62"/>
-                </a:solidFill>
-                <a:latin typeface="Calibri"/>
-              </a:rPr>
-              <a:t>105 / 105</a:t>
-            </a:r>
-          </a:p>
-        </p:txBody>
-      </p:sp>
-      <p:sp>
-        <p:nvSpPr>
-          <p:cNvPr id="36" name="TextBox 35"/>
-          <p:cNvSpPr txBox="1"/>
-          <p:nvPr/>
-        </p:nvSpPr>
-        <p:spPr>
-          <a:xfrm>
-            <a:off x="8549640" y="4325112"/>
-            <a:ext cx="2377440" cy="658368"/>
-          </a:xfrm>
-          <a:prstGeom prst="rect">
-            <a:avLst/>
-          </a:prstGeom>
-          <a:noFill/>
-        </p:spPr>
-        <p:txBody>
-          <a:bodyPr wrap="square" anchor="ctr" lIns="0" rIns="0" tIns="0" bIns="0">
-            <a:spAutoFit/>
-          </a:bodyPr>
-          <a:lstStyle/>
-          <a:p>
-            <a:pPr algn="ctr">
-              <a:lnSpc>
-                <a:spcPct val="115000"/>
-              </a:lnSpc>
-            </a:pPr>
-            <a:r>
-              <a:rPr sz="1700" b="0" i="0">
-                <a:solidFill>
-                  <a:srgbClr val="172420"/>
-                </a:solidFill>
-                <a:latin typeface="Calibri"/>
-              </a:rPr>
-              <a:t>105 / 105</a:t>
-            </a:r>
-          </a:p>
-        </p:txBody>
-      </p:sp>
-      <p:sp>
-        <p:nvSpPr>
-          <p:cNvPr id="37" name="Rounded Rectangle 36"/>
+          <p:cNvPr id="43" name="Rectangle 42"/>
           <p:cNvSpPr/>
           <p:nvPr/>
         </p:nvSpPr>
         <p:spPr>
           <a:xfrm>
             <a:off x="502920" y="5257800"/>
-            <a:ext cx="11183112" cy="914400"/>
-          </a:xfrm>
-          <a:prstGeom prst="roundRect">
-            <a:avLst>
-              <a:gd name="adj" fmla="val 8000"/>
-            </a:avLst>
+            <a:ext cx="54864" cy="914400"/>
+          </a:xfrm>
+          <a:prstGeom prst="rect">
+            <a:avLst/>
           </a:prstGeom>
           <a:solidFill>
-            <a:srgbClr val="FFFFFF"/>
+            <a:srgbClr val="C97A2B"/>
           </a:solidFill>
-          <a:ln w="12700">
-            <a:solidFill>
-              <a:srgbClr val="CFD6CB"/>
-            </a:solidFill>
+          <a:ln>
+            <a:noFill/>
           </a:ln>
           <a:effectLst/>
         </p:spPr>
@@ -12442,51 +12901,7 @@
       </p:sp>
       <p:sp>
         <p:nvSpPr>
-          <p:cNvPr id="38" name="Rectangle 37"/>
-          <p:cNvSpPr/>
-          <p:nvPr/>
-        </p:nvSpPr>
-        <p:spPr>
-          <a:xfrm>
-            <a:off x="502920" y="5257800"/>
-            <a:ext cx="54864" cy="914400"/>
-          </a:xfrm>
-          <a:prstGeom prst="rect">
-            <a:avLst/>
-          </a:prstGeom>
-          <a:solidFill>
-            <a:srgbClr val="C97A2B"/>
-          </a:solidFill>
-          <a:ln>
-            <a:noFill/>
-          </a:ln>
-          <a:effectLst/>
-        </p:spPr>
-        <p:style>
-          <a:lnRef idx="1">
-            <a:schemeClr val="accent1"/>
-          </a:lnRef>
-          <a:fillRef idx="3">
-            <a:schemeClr val="accent1"/>
-          </a:fillRef>
-          <a:effectRef idx="2">
-            <a:schemeClr val="accent1"/>
-          </a:effectRef>
-          <a:fontRef idx="minor">
-            <a:schemeClr val="lt1"/>
-          </a:fontRef>
-        </p:style>
-        <p:txBody>
-          <a:bodyPr rtlCol="0" anchor="ctr"/>
-          <a:lstStyle/>
-          <a:p>
-            <a:pPr algn="ctr"/>
-          </a:p>
-        </p:txBody>
-      </p:sp>
-      <p:sp>
-        <p:nvSpPr>
-          <p:cNvPr id="39" name="TextBox 38"/>
+          <p:cNvPr id="44" name="TextBox 43"/>
           <p:cNvSpPr txBox="1"/>
           <p:nvPr/>
         </p:nvSpPr>
@@ -12514,11 +12929,11 @@
             <a:r>
               <a:rPr sz="1500" b="1" i="0">
                 <a:solidFill>
-                  <a:srgbClr val="C97A2B"/>
-                </a:solidFill>
-                <a:latin typeface="Calibri"/>
-              </a:rPr>
-              <a:t>Answer: no.  </a:t>
+                  <a:srgbClr val="146B62"/>
+                </a:solidFill>
+                <a:latin typeface="Calibri"/>
+              </a:rPr>
+              <a:t>Answer: yes.  </a:t>
             </a:r>
             <a:r>
               <a:rPr sz="1350" b="0" i="0">
@@ -12527,7 +12942,7 @@
                 </a:solidFill>
                 <a:latin typeface="Calibri"/>
               </a:rPr>
-              <a:t>Mondrian caught a little more but flagged more honest clients; neither difference is significant (p = 0.21 and 0.18). One global threshold is enough.</a:t>
+              <a:t>Mondrian caught far more attacks (p &lt; 0.001) and kept accuracy higher during the attack (p = 0.007). Its cost, more honest updates flagged, is fixed by the second check: 0.7% in v2.</a:t>
             </a:r>
           </a:p>
         </p:txBody>
@@ -13163,7 +13578,7 @@
                 </a:solidFill>
                 <a:latin typeface="Calibri"/>
               </a:rPr>
-              <a:t>Federated nearly matches centralized; under attack Krypsis keeps accuracy higher.</a:t>
+              <a:t>Federated matches centralized; train, validation and test accuracy are equal on a fair 70 / 15 / 15 split, so no overfitting.</a:t>
             </a:r>
           </a:p>
         </p:txBody>
@@ -13287,7 +13702,7 @@
                 </a:solidFill>
                 <a:latin typeface="Calibri"/>
               </a:rPr>
-              <a:t>One global threshold is enough; Mondrian gave no significant gain.</a:t>
+              <a:t>Per-cluster (Mondrian) thresholds beat one global threshold on uneven routers; the second check removes their extra false alarms.</a:t>
             </a:r>
           </a:p>
         </p:txBody>
@@ -13411,7 +13826,7 @@
                 </a:solidFill>
                 <a:latin typeface="Calibri"/>
               </a:rPr>
-              <a:t>Protocol on the 11-class task, a trust-based weight cap, a real network testbed.</a:t>
+              <a:t>More FLNET2023 seeds, the 11-class task, a secret sketch seed, a real network testbed.</a:t>
             </a:r>
           </a:p>
         </p:txBody>
@@ -17311,7 +17726,7 @@
                 </a:solidFill>
                 <a:latin typeface="Calibri"/>
               </a:rPr>
-              <a:t>FLNET2023 records network flows at 10 routers. Five steps turn the raw captures into clean model input.</a:t>
+              <a:t>FLNET2023 records network flows at 10 routers. Five steps turn the raw captures into a clean 70 / 15 / 15 split.</a:t>
             </a:r>
           </a:p>
         </p:txBody>
@@ -17476,7 +17891,7 @@
                 </a:solidFill>
                 <a:latin typeface="Calibri"/>
               </a:rPr>
-              <a:t>Raw captures</a:t>
+              <a:t>Sample 10%</a:t>
             </a:r>
           </a:p>
           <a:p>
@@ -17492,7 +17907,7 @@
                 </a:solidFill>
                 <a:latin typeface="Calibri"/>
               </a:rPr>
-              <a:t>one CSV set per router · 4.8 M flows</a:t>
+              <a:t>of 4.8 M flows, ≥ 2,000 per file</a:t>
             </a:r>
           </a:p>
         </p:txBody>
@@ -17601,7 +18016,7 @@
                 </a:solidFill>
                 <a:latin typeface="Calibri"/>
               </a:rPr>
-              <a:t>Sample 10%</a:t>
+              <a:t>Drop identifiers</a:t>
             </a:r>
           </a:p>
           <a:p>
@@ -17617,7 +18032,7 @@
                 </a:solidFill>
                 <a:latin typeface="Calibri"/>
               </a:rPr>
-              <a:t>at least 2,000 rows per file</a:t>
+              <a:t>src/dst IP, source port, timestamp</a:t>
             </a:r>
           </a:p>
         </p:txBody>
@@ -17726,7 +18141,7 @@
                 </a:solidFill>
                 <a:latin typeface="Calibri"/>
               </a:rPr>
-              <a:t>Drop identifiers</a:t>
+              <a:t>Remove duplicates</a:t>
             </a:r>
           </a:p>
           <a:p>
@@ -17742,7 +18157,7 @@
                 </a:solidFill>
                 <a:latin typeface="Calibri"/>
               </a:rPr>
-              <a:t>src/dst IP, source port, timestamp</a:t>
+              <a:t>170,596 exact copies</a:t>
             </a:r>
           </a:p>
         </p:txBody>
@@ -17851,7 +18266,7 @@
                 </a:solidFill>
                 <a:latin typeface="Calibri"/>
               </a:rPr>
-              <a:t>Clean</a:t>
+              <a:t>Split 70 / 15 / 15</a:t>
             </a:r>
           </a:p>
           <a:p>
@@ -17867,7 +18282,7 @@
                 </a:solidFill>
                 <a:latin typeface="Calibri"/>
               </a:rPr>
-              <a:t>inf / NaN rows · 12 constant columns</a:t>
+              <a:t>train · validation · test, inside each router</a:t>
             </a:r>
           </a:p>
         </p:txBody>
@@ -17992,7 +18407,7 @@
                 </a:solidFill>
                 <a:latin typeface="Calibri"/>
               </a:rPr>
-              <a:t>signed log, then min-max to 0–1</a:t>
+              <a:t>signed log + min-max, fit on train only</a:t>
             </a:r>
           </a:p>
         </p:txBody>
@@ -18423,7 +18838,7 @@
                 </a:solidFill>
                 <a:latin typeface="Calibri"/>
               </a:rPr>
-              <a:t>Why log scaling?  </a:t>
+              <a:t>Why remove duplicates?  </a:t>
             </a:r>
             <a:r>
               <a:rPr sz="1200" b="0" i="0">
@@ -18432,7 +18847,7 @@
                 </a:solidFill>
                 <a:latin typeface="Calibri"/>
               </a:rPr>
-              <a:t>Byte and packet counts range from 1 to about a billion; the log stops a few huge flows from squashing the rest.</a:t>
+              <a:t>30% of flows were exact copies. A copy in both train and test would let the model pass by memory.</a:t>
             </a:r>
           </a:p>
         </p:txBody>
@@ -18515,7 +18930,7 @@
                 </a:solidFill>
                 <a:latin typeface="Calibri"/>
               </a:rPr>
-              <a:t>No test leakage  </a:t>
+              <a:t>Why 70 / 15 / 15?  </a:t>
             </a:r>
             <a:r>
               <a:rPr sz="1200" b="0" i="0">
@@ -18524,7 +18939,7 @@
                 </a:solidFill>
                 <a:latin typeface="Calibri"/>
               </a:rPr>
-              <a:t>The scaler is fitted on training data only. Result: 564,007 training and 79,491 test flows.</a:t>
+              <a:t>Train 275,381 · validation 59,012 (early stopping, threshold) · test 59,016, used once at the end.</a:t>
             </a:r>
           </a:p>
         </p:txBody>
@@ -18611,7 +19026,7 @@
                 </a:solidFill>
                 <a:latin typeface="Calibri"/>
               </a:rPr>
-              <a:t>TRAINING FLOWS BY TYPE</a:t>
+              <a:t>TRAINING FLOWS (70%) BY TYPE</a:t>
             </a:r>
           </a:p>
         </p:txBody>
@@ -18650,7 +19065,7 @@
                 </a:solidFill>
                 <a:latin typeface="Calibri"/>
               </a:rPr>
-              <a:t>Normal</a:t>
+              <a:t>DoS-hulk</a:t>
             </a:r>
           </a:p>
         </p:txBody>
@@ -18665,6 +19080,250 @@
           <a:xfrm>
             <a:off x="7955280" y="3493008"/>
             <a:ext cx="2651760" cy="155448"/>
+          </a:xfrm>
+          <a:prstGeom prst="rect">
+            <a:avLst/>
+          </a:prstGeom>
+          <a:solidFill>
+            <a:srgbClr val="146B62"/>
+          </a:solidFill>
+          <a:ln>
+            <a:noFill/>
+          </a:ln>
+          <a:effectLst/>
+        </p:spPr>
+        <p:style>
+          <a:lnRef idx="1">
+            <a:schemeClr val="accent1"/>
+          </a:lnRef>
+          <a:fillRef idx="3">
+            <a:schemeClr val="accent1"/>
+          </a:fillRef>
+          <a:effectRef idx="2">
+            <a:schemeClr val="accent1"/>
+          </a:effectRef>
+          <a:fontRef idx="minor">
+            <a:schemeClr val="lt1"/>
+          </a:fontRef>
+        </p:style>
+        <p:txBody>
+          <a:bodyPr rtlCol="0" anchor="ctr"/>
+          <a:lstStyle/>
+          <a:p>
+            <a:pPr algn="ctr"/>
+          </a:p>
+        </p:txBody>
+      </p:sp>
+      <p:sp>
+        <p:nvSpPr>
+          <p:cNvPr id="39" name="TextBox 38"/>
+          <p:cNvSpPr txBox="1"/>
+          <p:nvPr/>
+        </p:nvSpPr>
+        <p:spPr>
+          <a:xfrm>
+            <a:off x="10680192" y="3456432"/>
+            <a:ext cx="914400" cy="219456"/>
+          </a:xfrm>
+          <a:prstGeom prst="rect">
+            <a:avLst/>
+          </a:prstGeom>
+          <a:noFill/>
+        </p:spPr>
+        <p:txBody>
+          <a:bodyPr wrap="square" anchor="ctr" lIns="0" rIns="0" tIns="0" bIns="0">
+            <a:spAutoFit/>
+          </a:bodyPr>
+          <a:lstStyle/>
+          <a:p>
+            <a:pPr algn="l">
+              <a:lnSpc>
+                <a:spcPct val="115000"/>
+              </a:lnSpc>
+            </a:pPr>
+            <a:r>
+              <a:rPr sz="950" b="0" i="0">
+                <a:solidFill>
+                  <a:srgbClr val="56655D"/>
+                </a:solidFill>
+                <a:latin typeface="Calibri"/>
+              </a:rPr>
+              <a:t>114,900</a:t>
+            </a:r>
+          </a:p>
+        </p:txBody>
+      </p:sp>
+      <p:sp>
+        <p:nvSpPr>
+          <p:cNvPr id="40" name="TextBox 39"/>
+          <p:cNvSpPr txBox="1"/>
+          <p:nvPr/>
+        </p:nvSpPr>
+        <p:spPr>
+          <a:xfrm>
+            <a:off x="6446520" y="3703320"/>
+            <a:ext cx="1463040" cy="219456"/>
+          </a:xfrm>
+          <a:prstGeom prst="rect">
+            <a:avLst/>
+          </a:prstGeom>
+          <a:noFill/>
+        </p:spPr>
+        <p:txBody>
+          <a:bodyPr wrap="square" anchor="ctr" lIns="0" rIns="0" tIns="0" bIns="0">
+            <a:spAutoFit/>
+          </a:bodyPr>
+          <a:lstStyle/>
+          <a:p>
+            <a:pPr algn="r">
+              <a:lnSpc>
+                <a:spcPct val="115000"/>
+              </a:lnSpc>
+            </a:pPr>
+            <a:r>
+              <a:rPr sz="1000" b="0" i="0">
+                <a:solidFill>
+                  <a:srgbClr val="172420"/>
+                </a:solidFill>
+                <a:latin typeface="Calibri"/>
+              </a:rPr>
+              <a:t>DDoS-tcp</a:t>
+            </a:r>
+          </a:p>
+        </p:txBody>
+      </p:sp>
+      <p:sp>
+        <p:nvSpPr>
+          <p:cNvPr id="41" name="Rectangle 40"/>
+          <p:cNvSpPr/>
+          <p:nvPr/>
+        </p:nvSpPr>
+        <p:spPr>
+          <a:xfrm>
+            <a:off x="7955280" y="3739896"/>
+            <a:ext cx="1500079" cy="155448"/>
+          </a:xfrm>
+          <a:prstGeom prst="rect">
+            <a:avLst/>
+          </a:prstGeom>
+          <a:solidFill>
+            <a:srgbClr val="146B62"/>
+          </a:solidFill>
+          <a:ln>
+            <a:noFill/>
+          </a:ln>
+          <a:effectLst/>
+        </p:spPr>
+        <p:style>
+          <a:lnRef idx="1">
+            <a:schemeClr val="accent1"/>
+          </a:lnRef>
+          <a:fillRef idx="3">
+            <a:schemeClr val="accent1"/>
+          </a:fillRef>
+          <a:effectRef idx="2">
+            <a:schemeClr val="accent1"/>
+          </a:effectRef>
+          <a:fontRef idx="minor">
+            <a:schemeClr val="lt1"/>
+          </a:fontRef>
+        </p:style>
+        <p:txBody>
+          <a:bodyPr rtlCol="0" anchor="ctr"/>
+          <a:lstStyle/>
+          <a:p>
+            <a:pPr algn="ctr"/>
+          </a:p>
+        </p:txBody>
+      </p:sp>
+      <p:sp>
+        <p:nvSpPr>
+          <p:cNvPr id="42" name="TextBox 41"/>
+          <p:cNvSpPr txBox="1"/>
+          <p:nvPr/>
+        </p:nvSpPr>
+        <p:spPr>
+          <a:xfrm>
+            <a:off x="9528511" y="3703320"/>
+            <a:ext cx="914400" cy="219456"/>
+          </a:xfrm>
+          <a:prstGeom prst="rect">
+            <a:avLst/>
+          </a:prstGeom>
+          <a:noFill/>
+        </p:spPr>
+        <p:txBody>
+          <a:bodyPr wrap="square" anchor="ctr" lIns="0" rIns="0" tIns="0" bIns="0">
+            <a:spAutoFit/>
+          </a:bodyPr>
+          <a:lstStyle/>
+          <a:p>
+            <a:pPr algn="l">
+              <a:lnSpc>
+                <a:spcPct val="115000"/>
+              </a:lnSpc>
+            </a:pPr>
+            <a:r>
+              <a:rPr sz="950" b="0" i="0">
+                <a:solidFill>
+                  <a:srgbClr val="56655D"/>
+                </a:solidFill>
+                <a:latin typeface="Calibri"/>
+              </a:rPr>
+              <a:t>64,998</a:t>
+            </a:r>
+          </a:p>
+        </p:txBody>
+      </p:sp>
+      <p:sp>
+        <p:nvSpPr>
+          <p:cNvPr id="43" name="TextBox 42"/>
+          <p:cNvSpPr txBox="1"/>
+          <p:nvPr/>
+        </p:nvSpPr>
+        <p:spPr>
+          <a:xfrm>
+            <a:off x="6446520" y="3950208"/>
+            <a:ext cx="1463040" cy="219456"/>
+          </a:xfrm>
+          <a:prstGeom prst="rect">
+            <a:avLst/>
+          </a:prstGeom>
+          <a:noFill/>
+        </p:spPr>
+        <p:txBody>
+          <a:bodyPr wrap="square" anchor="ctr" lIns="0" rIns="0" tIns="0" bIns="0">
+            <a:spAutoFit/>
+          </a:bodyPr>
+          <a:lstStyle/>
+          <a:p>
+            <a:pPr algn="r">
+              <a:lnSpc>
+                <a:spcPct val="115000"/>
+              </a:lnSpc>
+            </a:pPr>
+            <a:r>
+              <a:rPr sz="1000" b="0" i="0">
+                <a:solidFill>
+                  <a:srgbClr val="172420"/>
+                </a:solidFill>
+                <a:latin typeface="Calibri"/>
+              </a:rPr>
+              <a:t>Normal</a:t>
+            </a:r>
+          </a:p>
+        </p:txBody>
+      </p:sp>
+      <p:sp>
+        <p:nvSpPr>
+          <p:cNvPr id="44" name="Rectangle 43"/>
+          <p:cNvSpPr/>
+          <p:nvPr/>
+        </p:nvSpPr>
+        <p:spPr>
+          <a:xfrm>
+            <a:off x="7955280" y="3986784"/>
+            <a:ext cx="650293" cy="155448"/>
           </a:xfrm>
           <a:prstGeom prst="rect">
             <a:avLst/>
@@ -18701,13 +19360,13 @@
       </p:sp>
       <p:sp>
         <p:nvSpPr>
-          <p:cNvPr id="39" name="TextBox 38"/>
+          <p:cNvPr id="45" name="TextBox 44"/>
           <p:cNvSpPr txBox="1"/>
           <p:nvPr/>
         </p:nvSpPr>
         <p:spPr>
           <a:xfrm>
-            <a:off x="10680192" y="3456432"/>
+            <a:off x="8678725" y="3950208"/>
             <a:ext cx="914400" cy="219456"/>
           </a:xfrm>
           <a:prstGeom prst="rect">
@@ -18733,20 +19392,20 @@
                 </a:solidFill>
                 <a:latin typeface="Calibri"/>
               </a:rPr>
-              <a:t>192,253</a:t>
-            </a:r>
-          </a:p>
-        </p:txBody>
-      </p:sp>
-      <p:sp>
-        <p:nvSpPr>
-          <p:cNvPr id="40" name="TextBox 39"/>
+              <a:t>28,177</a:t>
+            </a:r>
+          </a:p>
+        </p:txBody>
+      </p:sp>
+      <p:sp>
+        <p:nvSpPr>
+          <p:cNvPr id="46" name="TextBox 45"/>
           <p:cNvSpPr txBox="1"/>
           <p:nvPr/>
         </p:nvSpPr>
         <p:spPr>
           <a:xfrm>
-            <a:off x="6446520" y="3703320"/>
+            <a:off x="6446520" y="4197096"/>
             <a:ext cx="1463040" cy="219456"/>
           </a:xfrm>
           <a:prstGeom prst="rect">
@@ -18772,21 +19431,21 @@
                 </a:solidFill>
                 <a:latin typeface="Calibri"/>
               </a:rPr>
-              <a:t>DoS-hulk</a:t>
-            </a:r>
-          </a:p>
-        </p:txBody>
-      </p:sp>
-      <p:sp>
-        <p:nvSpPr>
-          <p:cNvPr id="41" name="Rectangle 40"/>
+              <a:t>DDoS-stomp</a:t>
+            </a:r>
+          </a:p>
+        </p:txBody>
+      </p:sp>
+      <p:sp>
+        <p:nvSpPr>
+          <p:cNvPr id="47" name="Rectangle 46"/>
           <p:cNvSpPr/>
           <p:nvPr/>
         </p:nvSpPr>
         <p:spPr>
           <a:xfrm>
-            <a:off x="7955280" y="3739896"/>
-            <a:ext cx="2268106" cy="155448"/>
+            <a:off x="7955280" y="4233672"/>
+            <a:ext cx="629314" cy="155448"/>
           </a:xfrm>
           <a:prstGeom prst="rect">
             <a:avLst/>
@@ -18823,13 +19482,13 @@
       </p:sp>
       <p:sp>
         <p:nvSpPr>
-          <p:cNvPr id="42" name="TextBox 41"/>
+          <p:cNvPr id="48" name="TextBox 47"/>
           <p:cNvSpPr txBox="1"/>
           <p:nvPr/>
         </p:nvSpPr>
         <p:spPr>
           <a:xfrm>
-            <a:off x="10296538" y="3703320"/>
+            <a:off x="8657746" y="4197096"/>
             <a:ext cx="914400" cy="219456"/>
           </a:xfrm>
           <a:prstGeom prst="rect">
@@ -18855,20 +19514,20 @@
                 </a:solidFill>
                 <a:latin typeface="Calibri"/>
               </a:rPr>
-              <a:t>164,438</a:t>
-            </a:r>
-          </a:p>
-        </p:txBody>
-      </p:sp>
-      <p:sp>
-        <p:nvSpPr>
-          <p:cNvPr id="43" name="TextBox 42"/>
+              <a:t>27,268</a:t>
+            </a:r>
+          </a:p>
+        </p:txBody>
+      </p:sp>
+      <p:sp>
+        <p:nvSpPr>
+          <p:cNvPr id="49" name="TextBox 48"/>
           <p:cNvSpPr txBox="1"/>
           <p:nvPr/>
         </p:nvSpPr>
         <p:spPr>
           <a:xfrm>
-            <a:off x="6446520" y="3950208"/>
+            <a:off x="6446520" y="4443984"/>
             <a:ext cx="1463040" cy="219456"/>
           </a:xfrm>
           <a:prstGeom prst="rect">
@@ -18894,21 +19553,21 @@
                 </a:solidFill>
                 <a:latin typeface="Calibri"/>
               </a:rPr>
-              <a:t>DDoS-tcp</a:t>
-            </a:r>
-          </a:p>
-        </p:txBody>
-      </p:sp>
-      <p:sp>
-        <p:nvSpPr>
-          <p:cNvPr id="44" name="Rectangle 43"/>
+              <a:t>DDoS-dyn</a:t>
+            </a:r>
+          </a:p>
+        </p:txBody>
+      </p:sp>
+      <p:sp>
+        <p:nvSpPr>
+          <p:cNvPr id="50" name="Rectangle 49"/>
           <p:cNvSpPr/>
           <p:nvPr/>
         </p:nvSpPr>
         <p:spPr>
           <a:xfrm>
-            <a:off x="7955280" y="3986784"/>
-            <a:ext cx="1283859" cy="155448"/>
+            <a:off x="7955280" y="4480560"/>
+            <a:ext cx="486433" cy="155448"/>
           </a:xfrm>
           <a:prstGeom prst="rect">
             <a:avLst/>
@@ -18945,13 +19604,13 @@
       </p:sp>
       <p:sp>
         <p:nvSpPr>
-          <p:cNvPr id="45" name="TextBox 44"/>
+          <p:cNvPr id="51" name="TextBox 50"/>
           <p:cNvSpPr txBox="1"/>
           <p:nvPr/>
         </p:nvSpPr>
         <p:spPr>
           <a:xfrm>
-            <a:off x="9312291" y="3950208"/>
+            <a:off x="8514865" y="4443984"/>
             <a:ext cx="914400" cy="219456"/>
           </a:xfrm>
           <a:prstGeom prst="rect">
@@ -18977,20 +19636,20 @@
                 </a:solidFill>
                 <a:latin typeface="Calibri"/>
               </a:rPr>
-              <a:t>93,080</a:t>
-            </a:r>
-          </a:p>
-        </p:txBody>
-      </p:sp>
-      <p:sp>
-        <p:nvSpPr>
-          <p:cNvPr id="46" name="TextBox 45"/>
+              <a:t>21,077</a:t>
+            </a:r>
+          </a:p>
+        </p:txBody>
+      </p:sp>
+      <p:sp>
+        <p:nvSpPr>
+          <p:cNvPr id="52" name="TextBox 51"/>
           <p:cNvSpPr txBox="1"/>
           <p:nvPr/>
         </p:nvSpPr>
         <p:spPr>
           <a:xfrm>
-            <a:off x="6446520" y="4197096"/>
+            <a:off x="6446520" y="4690872"/>
             <a:ext cx="1463040" cy="219456"/>
           </a:xfrm>
           <a:prstGeom prst="rect">
@@ -19016,21 +19675,21 @@
                 </a:solidFill>
                 <a:latin typeface="Calibri"/>
               </a:rPr>
-              <a:t>DDoS-stomp</a:t>
-            </a:r>
-          </a:p>
-        </p:txBody>
-      </p:sp>
-      <p:sp>
-        <p:nvSpPr>
-          <p:cNvPr id="47" name="Rectangle 46"/>
+              <a:t>DoS-slowhttp</a:t>
+            </a:r>
+          </a:p>
+        </p:txBody>
+      </p:sp>
+      <p:sp>
+        <p:nvSpPr>
+          <p:cNvPr id="53" name="Rectangle 52"/>
           <p:cNvSpPr/>
           <p:nvPr/>
         </p:nvSpPr>
         <p:spPr>
           <a:xfrm>
-            <a:off x="7955280" y="4233672"/>
-            <a:ext cx="537295" cy="155448"/>
+            <a:off x="7955280" y="4727448"/>
+            <a:ext cx="232104" cy="155448"/>
           </a:xfrm>
           <a:prstGeom prst="rect">
             <a:avLst/>
@@ -19067,13 +19726,13 @@
       </p:sp>
       <p:sp>
         <p:nvSpPr>
-          <p:cNvPr id="48" name="TextBox 47"/>
+          <p:cNvPr id="54" name="TextBox 53"/>
           <p:cNvSpPr txBox="1"/>
           <p:nvPr/>
         </p:nvSpPr>
         <p:spPr>
           <a:xfrm>
-            <a:off x="8565727" y="4197096"/>
+            <a:off x="8260536" y="4690872"/>
             <a:ext cx="914400" cy="219456"/>
           </a:xfrm>
           <a:prstGeom prst="rect">
@@ -19099,20 +19758,20 @@
                 </a:solidFill>
                 <a:latin typeface="Calibri"/>
               </a:rPr>
-              <a:t>38,954</a:t>
-            </a:r>
-          </a:p>
-        </p:txBody>
-      </p:sp>
-      <p:sp>
-        <p:nvSpPr>
-          <p:cNvPr id="49" name="TextBox 48"/>
+              <a:t>10,057</a:t>
+            </a:r>
+          </a:p>
+        </p:txBody>
+      </p:sp>
+      <p:sp>
+        <p:nvSpPr>
+          <p:cNvPr id="55" name="TextBox 54"/>
           <p:cNvSpPr txBox="1"/>
           <p:nvPr/>
         </p:nvSpPr>
         <p:spPr>
           <a:xfrm>
-            <a:off x="6446520" y="4443984"/>
+            <a:off x="6446520" y="4937760"/>
             <a:ext cx="1463040" cy="219456"/>
           </a:xfrm>
           <a:prstGeom prst="rect">
@@ -19138,21 +19797,21 @@
                 </a:solidFill>
                 <a:latin typeface="Calibri"/>
               </a:rPr>
-              <a:t>DDoS-dyn</a:t>
-            </a:r>
-          </a:p>
-        </p:txBody>
-      </p:sp>
-      <p:sp>
-        <p:nvSpPr>
-          <p:cNvPr id="50" name="Rectangle 49"/>
+              <a:t>DDoS-bot</a:t>
+            </a:r>
+          </a:p>
+        </p:txBody>
+      </p:sp>
+      <p:sp>
+        <p:nvSpPr>
+          <p:cNvPr id="56" name="Rectangle 55"/>
           <p:cNvSpPr/>
           <p:nvPr/>
         </p:nvSpPr>
         <p:spPr>
           <a:xfrm>
-            <a:off x="7955280" y="4480560"/>
-            <a:ext cx="445406" cy="155448"/>
+            <a:off x="7955280" y="4974336"/>
+            <a:ext cx="141635" cy="155448"/>
           </a:xfrm>
           <a:prstGeom prst="rect">
             <a:avLst/>
@@ -19189,13 +19848,13 @@
       </p:sp>
       <p:sp>
         <p:nvSpPr>
-          <p:cNvPr id="51" name="TextBox 50"/>
+          <p:cNvPr id="57" name="TextBox 56"/>
           <p:cNvSpPr txBox="1"/>
           <p:nvPr/>
         </p:nvSpPr>
         <p:spPr>
           <a:xfrm>
-            <a:off x="8473838" y="4443984"/>
+            <a:off x="8170067" y="4937760"/>
             <a:ext cx="914400" cy="219456"/>
           </a:xfrm>
           <a:prstGeom prst="rect">
@@ -19221,20 +19880,20 @@
                 </a:solidFill>
                 <a:latin typeface="Calibri"/>
               </a:rPr>
-              <a:t>32,292</a:t>
-            </a:r>
-          </a:p>
-        </p:txBody>
-      </p:sp>
-      <p:sp>
-        <p:nvSpPr>
-          <p:cNvPr id="52" name="TextBox 51"/>
+              <a:t>6,137</a:t>
+            </a:r>
+          </a:p>
+        </p:txBody>
+      </p:sp>
+      <p:sp>
+        <p:nvSpPr>
+          <p:cNvPr id="58" name="TextBox 57"/>
           <p:cNvSpPr txBox="1"/>
           <p:nvPr/>
         </p:nvSpPr>
         <p:spPr>
           <a:xfrm>
-            <a:off x="6446520" y="4690872"/>
+            <a:off x="6446520" y="5184648"/>
             <a:ext cx="1463040" cy="219456"/>
           </a:xfrm>
           <a:prstGeom prst="rect">
@@ -19260,21 +19919,21 @@
                 </a:solidFill>
                 <a:latin typeface="Calibri"/>
               </a:rPr>
-              <a:t>Infiltration-MITM</a:t>
-            </a:r>
-          </a:p>
-        </p:txBody>
-      </p:sp>
-      <p:sp>
-        <p:nvSpPr>
-          <p:cNvPr id="53" name="Rectangle 52"/>
+              <a:t>Web-XSS</a:t>
+            </a:r>
+          </a:p>
+        </p:txBody>
+      </p:sp>
+      <p:sp>
+        <p:nvSpPr>
+          <p:cNvPr id="59" name="Rectangle 58"/>
           <p:cNvSpPr/>
           <p:nvPr/>
         </p:nvSpPr>
         <p:spPr>
           <a:xfrm>
-            <a:off x="7955280" y="4727448"/>
-            <a:ext cx="220689" cy="155448"/>
+            <a:off x="7955280" y="5221224"/>
+            <a:ext cx="49550" cy="155448"/>
           </a:xfrm>
           <a:prstGeom prst="rect">
             <a:avLst/>
@@ -19311,13 +19970,13 @@
       </p:sp>
       <p:sp>
         <p:nvSpPr>
-          <p:cNvPr id="54" name="TextBox 53"/>
+          <p:cNvPr id="60" name="TextBox 59"/>
           <p:cNvSpPr txBox="1"/>
           <p:nvPr/>
         </p:nvSpPr>
         <p:spPr>
           <a:xfrm>
-            <a:off x="8249121" y="4690872"/>
+            <a:off x="8077982" y="5184648"/>
             <a:ext cx="914400" cy="219456"/>
           </a:xfrm>
           <a:prstGeom prst="rect">
@@ -19343,20 +20002,20 @@
                 </a:solidFill>
                 <a:latin typeface="Calibri"/>
               </a:rPr>
-              <a:t>16,000</a:t>
-            </a:r>
-          </a:p>
-        </p:txBody>
-      </p:sp>
-      <p:sp>
-        <p:nvSpPr>
-          <p:cNvPr id="55" name="TextBox 54"/>
+              <a:t>2,147</a:t>
+            </a:r>
+          </a:p>
+        </p:txBody>
+      </p:sp>
+      <p:sp>
+        <p:nvSpPr>
+          <p:cNvPr id="61" name="TextBox 60"/>
           <p:cNvSpPr txBox="1"/>
           <p:nvPr/>
         </p:nvSpPr>
         <p:spPr>
           <a:xfrm>
-            <a:off x="6446520" y="4937760"/>
+            <a:off x="6446520" y="5431536"/>
             <a:ext cx="1463040" cy="219456"/>
           </a:xfrm>
           <a:prstGeom prst="rect">
@@ -19382,21 +20041,21 @@
                 </a:solidFill>
                 <a:latin typeface="Calibri"/>
               </a:rPr>
-              <a:t>DoS-slowhttp</a:t>
-            </a:r>
-          </a:p>
-        </p:txBody>
-      </p:sp>
-      <p:sp>
-        <p:nvSpPr>
-          <p:cNvPr id="56" name="Rectangle 55"/>
+              <a:t>Web-SQL-injection</a:t>
+            </a:r>
+          </a:p>
+        </p:txBody>
+      </p:sp>
+      <p:sp>
+        <p:nvSpPr>
+          <p:cNvPr id="62" name="Rectangle 61"/>
           <p:cNvSpPr/>
           <p:nvPr/>
         </p:nvSpPr>
         <p:spPr>
           <a:xfrm>
-            <a:off x="7955280" y="4974336"/>
-            <a:ext cx="198193" cy="155448"/>
+            <a:off x="7955280" y="5468112"/>
+            <a:ext cx="27432" cy="155448"/>
           </a:xfrm>
           <a:prstGeom prst="rect">
             <a:avLst/>
@@ -19433,13 +20092,13 @@
       </p:sp>
       <p:sp>
         <p:nvSpPr>
-          <p:cNvPr id="57" name="TextBox 56"/>
+          <p:cNvPr id="63" name="TextBox 62"/>
           <p:cNvSpPr txBox="1"/>
           <p:nvPr/>
         </p:nvSpPr>
         <p:spPr>
           <a:xfrm>
-            <a:off x="8226625" y="4937760"/>
+            <a:off x="8055864" y="5431536"/>
             <a:ext cx="914400" cy="219456"/>
           </a:xfrm>
           <a:prstGeom prst="rect">
@@ -19465,20 +20124,20 @@
                 </a:solidFill>
                 <a:latin typeface="Calibri"/>
               </a:rPr>
-              <a:t>14,369</a:t>
-            </a:r>
-          </a:p>
-        </p:txBody>
-      </p:sp>
-      <p:sp>
-        <p:nvSpPr>
-          <p:cNvPr id="58" name="TextBox 57"/>
+              <a:t>309</a:t>
+            </a:r>
+          </a:p>
+        </p:txBody>
+      </p:sp>
+      <p:sp>
+        <p:nvSpPr>
+          <p:cNvPr id="64" name="TextBox 63"/>
           <p:cNvSpPr txBox="1"/>
           <p:nvPr/>
         </p:nvSpPr>
         <p:spPr>
           <a:xfrm>
-            <a:off x="6446520" y="5184648"/>
+            <a:off x="6446520" y="5678424"/>
             <a:ext cx="1463040" cy="219456"/>
           </a:xfrm>
           <a:prstGeom prst="rect">
@@ -19504,21 +20163,21 @@
                 </a:solidFill>
                 <a:latin typeface="Calibri"/>
               </a:rPr>
-              <a:t>DDoS-bot</a:t>
-            </a:r>
-          </a:p>
-        </p:txBody>
-      </p:sp>
-      <p:sp>
-        <p:nvSpPr>
-          <p:cNvPr id="59" name="Rectangle 58"/>
+              <a:t>Web-cmd-injection</a:t>
+            </a:r>
+          </a:p>
+        </p:txBody>
+      </p:sp>
+      <p:sp>
+        <p:nvSpPr>
+          <p:cNvPr id="65" name="Rectangle 64"/>
           <p:cNvSpPr/>
           <p:nvPr/>
         </p:nvSpPr>
         <p:spPr>
           <a:xfrm>
-            <a:off x="7955280" y="5221224"/>
-            <a:ext cx="121117" cy="155448"/>
+            <a:off x="7955280" y="5715000"/>
+            <a:ext cx="27432" cy="155448"/>
           </a:xfrm>
           <a:prstGeom prst="rect">
             <a:avLst/>
@@ -19555,13 +20214,13 @@
       </p:sp>
       <p:sp>
         <p:nvSpPr>
-          <p:cNvPr id="60" name="TextBox 59"/>
+          <p:cNvPr id="66" name="TextBox 65"/>
           <p:cNvSpPr txBox="1"/>
           <p:nvPr/>
         </p:nvSpPr>
         <p:spPr>
           <a:xfrm>
-            <a:off x="8149549" y="5184648"/>
+            <a:off x="8055864" y="5678424"/>
             <a:ext cx="914400" cy="219456"/>
           </a:xfrm>
           <a:prstGeom prst="rect">
@@ -19587,20 +20246,20 @@
                 </a:solidFill>
                 <a:latin typeface="Calibri"/>
               </a:rPr>
-              <a:t>8,781</a:t>
-            </a:r>
-          </a:p>
-        </p:txBody>
-      </p:sp>
-      <p:sp>
-        <p:nvSpPr>
-          <p:cNvPr id="61" name="TextBox 60"/>
+              <a:t>231</a:t>
+            </a:r>
+          </a:p>
+        </p:txBody>
+      </p:sp>
+      <p:sp>
+        <p:nvSpPr>
+          <p:cNvPr id="67" name="TextBox 66"/>
           <p:cNvSpPr txBox="1"/>
           <p:nvPr/>
         </p:nvSpPr>
         <p:spPr>
           <a:xfrm>
-            <a:off x="6446520" y="5431536"/>
+            <a:off x="6446520" y="5925312"/>
             <a:ext cx="1463040" cy="219456"/>
           </a:xfrm>
           <a:prstGeom prst="rect">
@@ -19626,21 +20285,21 @@
                 </a:solidFill>
                 <a:latin typeface="Calibri"/>
               </a:rPr>
-              <a:t>Web-XSS</a:t>
-            </a:r>
-          </a:p>
-        </p:txBody>
-      </p:sp>
-      <p:sp>
-        <p:nvSpPr>
-          <p:cNvPr id="62" name="Rectangle 61"/>
+              <a:t>Infiltration-MITM</a:t>
+            </a:r>
+          </a:p>
+        </p:txBody>
+      </p:sp>
+      <p:sp>
+        <p:nvSpPr>
+          <p:cNvPr id="68" name="Rectangle 67"/>
           <p:cNvSpPr/>
           <p:nvPr/>
         </p:nvSpPr>
         <p:spPr>
           <a:xfrm>
-            <a:off x="7955280" y="5468112"/>
-            <a:ext cx="42331" cy="155448"/>
+            <a:off x="7955280" y="5961888"/>
+            <a:ext cx="27432" cy="155448"/>
           </a:xfrm>
           <a:prstGeom prst="rect">
             <a:avLst/>
@@ -19677,13 +20336,13 @@
       </p:sp>
       <p:sp>
         <p:nvSpPr>
-          <p:cNvPr id="63" name="TextBox 62"/>
+          <p:cNvPr id="69" name="TextBox 68"/>
           <p:cNvSpPr txBox="1"/>
           <p:nvPr/>
         </p:nvSpPr>
         <p:spPr>
           <a:xfrm>
-            <a:off x="8070763" y="5431536"/>
+            <a:off x="8055864" y="5925312"/>
             <a:ext cx="914400" cy="219456"/>
           </a:xfrm>
           <a:prstGeom prst="rect">
@@ -19709,251 +20368,7 @@
                 </a:solidFill>
                 <a:latin typeface="Calibri"/>
               </a:rPr>
-              <a:t>3,069</a:t>
-            </a:r>
-          </a:p>
-        </p:txBody>
-      </p:sp>
-      <p:sp>
-        <p:nvSpPr>
-          <p:cNvPr id="64" name="TextBox 63"/>
-          <p:cNvSpPr txBox="1"/>
-          <p:nvPr/>
-        </p:nvSpPr>
-        <p:spPr>
-          <a:xfrm>
-            <a:off x="6446520" y="5678424"/>
-            <a:ext cx="1463040" cy="219456"/>
-          </a:xfrm>
-          <a:prstGeom prst="rect">
-            <a:avLst/>
-          </a:prstGeom>
-          <a:noFill/>
-        </p:spPr>
-        <p:txBody>
-          <a:bodyPr wrap="square" anchor="ctr" lIns="0" rIns="0" tIns="0" bIns="0">
-            <a:spAutoFit/>
-          </a:bodyPr>
-          <a:lstStyle/>
-          <a:p>
-            <a:pPr algn="r">
-              <a:lnSpc>
-                <a:spcPct val="115000"/>
-              </a:lnSpc>
-            </a:pPr>
-            <a:r>
-              <a:rPr sz="1000" b="0" i="0">
-                <a:solidFill>
-                  <a:srgbClr val="172420"/>
-                </a:solidFill>
-                <a:latin typeface="Calibri"/>
-              </a:rPr>
-              <a:t>Web-SQL-injection</a:t>
-            </a:r>
-          </a:p>
-        </p:txBody>
-      </p:sp>
-      <p:sp>
-        <p:nvSpPr>
-          <p:cNvPr id="65" name="Rectangle 64"/>
-          <p:cNvSpPr/>
-          <p:nvPr/>
-        </p:nvSpPr>
-        <p:spPr>
-          <a:xfrm>
-            <a:off x="7955280" y="5715000"/>
-            <a:ext cx="27432" cy="155448"/>
-          </a:xfrm>
-          <a:prstGeom prst="rect">
-            <a:avLst/>
-          </a:prstGeom>
-          <a:solidFill>
-            <a:srgbClr val="146B62"/>
-          </a:solidFill>
-          <a:ln>
-            <a:noFill/>
-          </a:ln>
-          <a:effectLst/>
-        </p:spPr>
-        <p:style>
-          <a:lnRef idx="1">
-            <a:schemeClr val="accent1"/>
-          </a:lnRef>
-          <a:fillRef idx="3">
-            <a:schemeClr val="accent1"/>
-          </a:fillRef>
-          <a:effectRef idx="2">
-            <a:schemeClr val="accent1"/>
-          </a:effectRef>
-          <a:fontRef idx="minor">
-            <a:schemeClr val="lt1"/>
-          </a:fontRef>
-        </p:style>
-        <p:txBody>
-          <a:bodyPr rtlCol="0" anchor="ctr"/>
-          <a:lstStyle/>
-          <a:p>
-            <a:pPr algn="ctr"/>
-          </a:p>
-        </p:txBody>
-      </p:sp>
-      <p:sp>
-        <p:nvSpPr>
-          <p:cNvPr id="66" name="TextBox 65"/>
-          <p:cNvSpPr txBox="1"/>
-          <p:nvPr/>
-        </p:nvSpPr>
-        <p:spPr>
-          <a:xfrm>
-            <a:off x="8055864" y="5678424"/>
-            <a:ext cx="914400" cy="219456"/>
-          </a:xfrm>
-          <a:prstGeom prst="rect">
-            <a:avLst/>
-          </a:prstGeom>
-          <a:noFill/>
-        </p:spPr>
-        <p:txBody>
-          <a:bodyPr wrap="square" anchor="ctr" lIns="0" rIns="0" tIns="0" bIns="0">
-            <a:spAutoFit/>
-          </a:bodyPr>
-          <a:lstStyle/>
-          <a:p>
-            <a:pPr algn="l">
-              <a:lnSpc>
-                <a:spcPct val="115000"/>
-              </a:lnSpc>
-            </a:pPr>
-            <a:r>
-              <a:rPr sz="950" b="0" i="0">
-                <a:solidFill>
-                  <a:srgbClr val="56655D"/>
-                </a:solidFill>
-                <a:latin typeface="Calibri"/>
-              </a:rPr>
-              <a:t>441</a:t>
-            </a:r>
-          </a:p>
-        </p:txBody>
-      </p:sp>
-      <p:sp>
-        <p:nvSpPr>
-          <p:cNvPr id="67" name="TextBox 66"/>
-          <p:cNvSpPr txBox="1"/>
-          <p:nvPr/>
-        </p:nvSpPr>
-        <p:spPr>
-          <a:xfrm>
-            <a:off x="6446520" y="5925312"/>
-            <a:ext cx="1463040" cy="219456"/>
-          </a:xfrm>
-          <a:prstGeom prst="rect">
-            <a:avLst/>
-          </a:prstGeom>
-          <a:noFill/>
-        </p:spPr>
-        <p:txBody>
-          <a:bodyPr wrap="square" anchor="ctr" lIns="0" rIns="0" tIns="0" bIns="0">
-            <a:spAutoFit/>
-          </a:bodyPr>
-          <a:lstStyle/>
-          <a:p>
-            <a:pPr algn="r">
-              <a:lnSpc>
-                <a:spcPct val="115000"/>
-              </a:lnSpc>
-            </a:pPr>
-            <a:r>
-              <a:rPr sz="1000" b="0" i="0">
-                <a:solidFill>
-                  <a:srgbClr val="172420"/>
-                </a:solidFill>
-                <a:latin typeface="Calibri"/>
-              </a:rPr>
-              <a:t>Web-cmd-injection</a:t>
-            </a:r>
-          </a:p>
-        </p:txBody>
-      </p:sp>
-      <p:sp>
-        <p:nvSpPr>
-          <p:cNvPr id="68" name="Rectangle 67"/>
-          <p:cNvSpPr/>
-          <p:nvPr/>
-        </p:nvSpPr>
-        <p:spPr>
-          <a:xfrm>
-            <a:off x="7955280" y="5961888"/>
-            <a:ext cx="27432" cy="155448"/>
-          </a:xfrm>
-          <a:prstGeom prst="rect">
-            <a:avLst/>
-          </a:prstGeom>
-          <a:solidFill>
-            <a:srgbClr val="146B62"/>
-          </a:solidFill>
-          <a:ln>
-            <a:noFill/>
-          </a:ln>
-          <a:effectLst/>
-        </p:spPr>
-        <p:style>
-          <a:lnRef idx="1">
-            <a:schemeClr val="accent1"/>
-          </a:lnRef>
-          <a:fillRef idx="3">
-            <a:schemeClr val="accent1"/>
-          </a:fillRef>
-          <a:effectRef idx="2">
-            <a:schemeClr val="accent1"/>
-          </a:effectRef>
-          <a:fontRef idx="minor">
-            <a:schemeClr val="lt1"/>
-          </a:fontRef>
-        </p:style>
-        <p:txBody>
-          <a:bodyPr rtlCol="0" anchor="ctr"/>
-          <a:lstStyle/>
-          <a:p>
-            <a:pPr algn="ctr"/>
-          </a:p>
-        </p:txBody>
-      </p:sp>
-      <p:sp>
-        <p:nvSpPr>
-          <p:cNvPr id="69" name="TextBox 68"/>
-          <p:cNvSpPr txBox="1"/>
-          <p:nvPr/>
-        </p:nvSpPr>
-        <p:spPr>
-          <a:xfrm>
-            <a:off x="8055864" y="5925312"/>
-            <a:ext cx="914400" cy="219456"/>
-          </a:xfrm>
-          <a:prstGeom prst="rect">
-            <a:avLst/>
-          </a:prstGeom>
-          <a:noFill/>
-        </p:spPr>
-        <p:txBody>
-          <a:bodyPr wrap="square" anchor="ctr" lIns="0" rIns="0" tIns="0" bIns="0">
-            <a:spAutoFit/>
-          </a:bodyPr>
-          <a:lstStyle/>
-          <a:p>
-            <a:pPr algn="l">
-              <a:lnSpc>
-                <a:spcPct val="115000"/>
-              </a:lnSpc>
-            </a:pPr>
-            <a:r>
-              <a:rPr sz="950" b="0" i="0">
-                <a:solidFill>
-                  <a:srgbClr val="56655D"/>
-                </a:solidFill>
-                <a:latin typeface="Calibri"/>
-              </a:rPr>
-              <a:t>330</a:t>
+              <a:t>80</a:t>
             </a:r>
           </a:p>
         </p:txBody>
@@ -20411,8 +20826,8 @@
         </p:nvSpPr>
         <p:spPr>
           <a:xfrm>
-            <a:off x="747129" y="3281782"/>
-            <a:ext cx="200126" cy="814730"/>
+            <a:off x="747129" y="2989219"/>
+            <a:ext cx="200126" cy="1107293"/>
           </a:xfrm>
           <a:prstGeom prst="rect">
             <a:avLst/>
@@ -20455,7 +20870,7 @@
         </p:nvSpPr>
         <p:spPr>
           <a:xfrm>
-            <a:off x="655689" y="3080614"/>
+            <a:off x="655689" y="2788051"/>
             <a:ext cx="383006" cy="182880"/>
           </a:xfrm>
           <a:prstGeom prst="rect">
@@ -20481,7 +20896,7 @@
                 </a:solidFill>
                 <a:latin typeface="Calibri"/>
               </a:rPr>
-              <a:t>66</a:t>
+              <a:t>90</a:t>
             </a:r>
           </a:p>
         </p:txBody>
@@ -20533,8 +20948,8 @@
         </p:nvSpPr>
         <p:spPr>
           <a:xfrm>
-            <a:off x="1069912" y="3278078"/>
-            <a:ext cx="200126" cy="818434"/>
+            <a:off x="1069912" y="2986750"/>
+            <a:ext cx="200126" cy="1109762"/>
           </a:xfrm>
           <a:prstGeom prst="rect">
             <a:avLst/>
@@ -20577,7 +20992,7 @@
         </p:nvSpPr>
         <p:spPr>
           <a:xfrm>
-            <a:off x="978472" y="3076910"/>
+            <a:off x="978472" y="2785582"/>
             <a:ext cx="383006" cy="182880"/>
           </a:xfrm>
           <a:prstGeom prst="rect">
@@ -20603,7 +21018,7 @@
                 </a:solidFill>
                 <a:latin typeface="Calibri"/>
               </a:rPr>
-              <a:t>66</a:t>
+              <a:t>90</a:t>
             </a:r>
           </a:p>
         </p:txBody>
@@ -20655,8 +21070,8 @@
         </p:nvSpPr>
         <p:spPr>
           <a:xfrm>
-            <a:off x="1392695" y="3285485"/>
-            <a:ext cx="200126" cy="811027"/>
+            <a:off x="1392695" y="2987985"/>
+            <a:ext cx="200126" cy="1108527"/>
           </a:xfrm>
           <a:prstGeom prst="rect">
             <a:avLst/>
@@ -20699,7 +21114,7 @@
         </p:nvSpPr>
         <p:spPr>
           <a:xfrm>
-            <a:off x="1301255" y="3084317"/>
+            <a:off x="1301255" y="2786817"/>
             <a:ext cx="383006" cy="182880"/>
           </a:xfrm>
           <a:prstGeom prst="rect">
@@ -20725,7 +21140,7 @@
                 </a:solidFill>
                 <a:latin typeface="Calibri"/>
               </a:rPr>
-              <a:t>66</a:t>
+              <a:t>90</a:t>
             </a:r>
           </a:p>
         </p:txBody>
@@ -20777,8 +21192,8 @@
         </p:nvSpPr>
         <p:spPr>
           <a:xfrm>
-            <a:off x="1715478" y="3286719"/>
-            <a:ext cx="200126" cy="809793"/>
+            <a:off x="1715478" y="2987985"/>
+            <a:ext cx="200126" cy="1108527"/>
           </a:xfrm>
           <a:prstGeom prst="rect">
             <a:avLst/>
@@ -20821,7 +21236,7 @@
         </p:nvSpPr>
         <p:spPr>
           <a:xfrm>
-            <a:off x="1624038" y="3085551"/>
+            <a:off x="1624038" y="2786817"/>
             <a:ext cx="383006" cy="182880"/>
           </a:xfrm>
           <a:prstGeom prst="rect">
@@ -20847,7 +21262,7 @@
                 </a:solidFill>
                 <a:latin typeface="Calibri"/>
               </a:rPr>
-              <a:t>66</a:t>
+              <a:t>90</a:t>
             </a:r>
           </a:p>
         </p:txBody>
@@ -20899,8 +21314,8 @@
         </p:nvSpPr>
         <p:spPr>
           <a:xfrm>
-            <a:off x="2038262" y="3284250"/>
-            <a:ext cx="200126" cy="812262"/>
+            <a:off x="2038262" y="2992923"/>
+            <a:ext cx="200126" cy="1103589"/>
           </a:xfrm>
           <a:prstGeom prst="rect">
             <a:avLst/>
@@ -20943,7 +21358,7 @@
         </p:nvSpPr>
         <p:spPr>
           <a:xfrm>
-            <a:off x="1946822" y="3083082"/>
+            <a:off x="1946822" y="2791755"/>
             <a:ext cx="383006" cy="182880"/>
           </a:xfrm>
           <a:prstGeom prst="rect">
@@ -20969,7 +21384,7 @@
                 </a:solidFill>
                 <a:latin typeface="Calibri"/>
               </a:rPr>
-              <a:t>66</a:t>
+              <a:t>89</a:t>
             </a:r>
           </a:p>
         </p:txBody>
@@ -21021,8 +21436,8 @@
         </p:nvSpPr>
         <p:spPr>
           <a:xfrm>
-            <a:off x="2361045" y="3284250"/>
-            <a:ext cx="200126" cy="812262"/>
+            <a:off x="2361045" y="2985516"/>
+            <a:ext cx="200126" cy="1110996"/>
           </a:xfrm>
           <a:prstGeom prst="rect">
             <a:avLst/>
@@ -21065,7 +21480,7 @@
         </p:nvSpPr>
         <p:spPr>
           <a:xfrm>
-            <a:off x="2269605" y="3083082"/>
+            <a:off x="2269605" y="2784348"/>
             <a:ext cx="383006" cy="182880"/>
           </a:xfrm>
           <a:prstGeom prst="rect">
@@ -21091,7 +21506,7 @@
                 </a:solidFill>
                 <a:latin typeface="Calibri"/>
               </a:rPr>
-              <a:t>66</a:t>
+              <a:t>90</a:t>
             </a:r>
           </a:p>
         </p:txBody>
@@ -21143,8 +21558,8 @@
         </p:nvSpPr>
         <p:spPr>
           <a:xfrm>
-            <a:off x="2683828" y="3278078"/>
-            <a:ext cx="200126" cy="818434"/>
+            <a:off x="2683828" y="2991688"/>
+            <a:ext cx="200126" cy="1104824"/>
           </a:xfrm>
           <a:prstGeom prst="rect">
             <a:avLst/>
@@ -21187,7 +21602,7 @@
         </p:nvSpPr>
         <p:spPr>
           <a:xfrm>
-            <a:off x="2592388" y="3076910"/>
+            <a:off x="2592388" y="2790520"/>
             <a:ext cx="383006" cy="182880"/>
           </a:xfrm>
           <a:prstGeom prst="rect">
@@ -21213,7 +21628,7 @@
                 </a:solidFill>
                 <a:latin typeface="Calibri"/>
               </a:rPr>
-              <a:t>66</a:t>
+              <a:t>90</a:t>
             </a:r>
           </a:p>
         </p:txBody>
@@ -21265,8 +21680,8 @@
         </p:nvSpPr>
         <p:spPr>
           <a:xfrm>
-            <a:off x="3006611" y="3286719"/>
-            <a:ext cx="200126" cy="809793"/>
+            <a:off x="3006611" y="2983047"/>
+            <a:ext cx="200126" cy="1113465"/>
           </a:xfrm>
           <a:prstGeom prst="rect">
             <a:avLst/>
@@ -21309,7 +21724,7 @@
         </p:nvSpPr>
         <p:spPr>
           <a:xfrm>
-            <a:off x="2915171" y="3085551"/>
+            <a:off x="2915171" y="2781879"/>
             <a:ext cx="383006" cy="182880"/>
           </a:xfrm>
           <a:prstGeom prst="rect">
@@ -21335,7 +21750,7 @@
                 </a:solidFill>
                 <a:latin typeface="Calibri"/>
               </a:rPr>
-              <a:t>66</a:t>
+              <a:t>90</a:t>
             </a:r>
           </a:p>
         </p:txBody>
@@ -21387,8 +21802,8 @@
         </p:nvSpPr>
         <p:spPr>
           <a:xfrm>
-            <a:off x="3329394" y="3280547"/>
-            <a:ext cx="200126" cy="815965"/>
+            <a:off x="3329394" y="2987985"/>
+            <a:ext cx="200126" cy="1108527"/>
           </a:xfrm>
           <a:prstGeom prst="rect">
             <a:avLst/>
@@ -21431,7 +21846,7 @@
         </p:nvSpPr>
         <p:spPr>
           <a:xfrm>
-            <a:off x="3237954" y="3079379"/>
+            <a:off x="3237954" y="2786817"/>
             <a:ext cx="383006" cy="182880"/>
           </a:xfrm>
           <a:prstGeom prst="rect">
@@ -21457,7 +21872,7 @@
                 </a:solidFill>
                 <a:latin typeface="Calibri"/>
               </a:rPr>
-              <a:t>66</a:t>
+              <a:t>90</a:t>
             </a:r>
           </a:p>
         </p:txBody>
@@ -21509,8 +21924,8 @@
         </p:nvSpPr>
         <p:spPr>
           <a:xfrm>
-            <a:off x="3652178" y="3280547"/>
-            <a:ext cx="200126" cy="815965"/>
+            <a:off x="3652178" y="2989219"/>
+            <a:ext cx="200126" cy="1107293"/>
           </a:xfrm>
           <a:prstGeom prst="rect">
             <a:avLst/>
@@ -21553,7 +21968,7 @@
         </p:nvSpPr>
         <p:spPr>
           <a:xfrm>
-            <a:off x="3560738" y="3079379"/>
+            <a:off x="3560738" y="2788051"/>
             <a:ext cx="383006" cy="182880"/>
           </a:xfrm>
           <a:prstGeom prst="rect">
@@ -21579,7 +21994,7 @@
                 </a:solidFill>
                 <a:latin typeface="Calibri"/>
               </a:rPr>
-              <a:t>66</a:t>
+              <a:t>90</a:t>
             </a:r>
           </a:p>
         </p:txBody>
@@ -21678,7 +22093,7 @@
                 </a:solidFill>
                 <a:latin typeface="Calibri"/>
               </a:rPr>
-              <a:t>All flows shuffled and dealt out evenly. Every client is about 66% attack, so everyone looks alike.</a:t>
+              <a:t>All flows shuffled and dealt out evenly. Every client is about 90% attack, so everyone looks alike.</a:t>
             </a:r>
           </a:p>
         </p:txBody>
@@ -21833,8 +22248,8 @@
         </p:nvSpPr>
         <p:spPr>
           <a:xfrm>
-            <a:off x="4541889" y="3408929"/>
-            <a:ext cx="200126" cy="687583"/>
+            <a:off x="4541889" y="3011439"/>
+            <a:ext cx="200126" cy="1085073"/>
           </a:xfrm>
           <a:prstGeom prst="rect">
             <a:avLst/>
@@ -21877,7 +22292,7 @@
         </p:nvSpPr>
         <p:spPr>
           <a:xfrm>
-            <a:off x="4450449" y="3207761"/>
+            <a:off x="4450449" y="2810271"/>
             <a:ext cx="383006" cy="182880"/>
           </a:xfrm>
           <a:prstGeom prst="rect">
@@ -21903,7 +22318,7 @@
                 </a:solidFill>
                 <a:latin typeface="Calibri"/>
               </a:rPr>
-              <a:t>56</a:t>
+              <a:t>88</a:t>
             </a:r>
           </a:p>
         </p:txBody>
@@ -21955,8 +22370,8 @@
         </p:nvSpPr>
         <p:spPr>
           <a:xfrm>
-            <a:off x="4864672" y="3069458"/>
-            <a:ext cx="200126" cy="1027054"/>
+            <a:off x="4864672" y="2950952"/>
+            <a:ext cx="200126" cy="1145560"/>
           </a:xfrm>
           <a:prstGeom prst="rect">
             <a:avLst/>
@@ -21999,7 +22414,7 @@
         </p:nvSpPr>
         <p:spPr>
           <a:xfrm>
-            <a:off x="4773232" y="2868290"/>
+            <a:off x="4773232" y="2749784"/>
             <a:ext cx="383006" cy="182880"/>
           </a:xfrm>
           <a:prstGeom prst="rect">
@@ -22025,7 +22440,7 @@
                 </a:solidFill>
                 <a:latin typeface="Calibri"/>
               </a:rPr>
-              <a:t>83</a:t>
+              <a:t>93</a:t>
             </a:r>
           </a:p>
         </p:txBody>
@@ -22077,8 +22492,8 @@
         </p:nvSpPr>
         <p:spPr>
           <a:xfrm>
-            <a:off x="5187455" y="3861968"/>
-            <a:ext cx="200126" cy="234544"/>
+            <a:off x="5187455" y="3548421"/>
+            <a:ext cx="200126" cy="548091"/>
           </a:xfrm>
           <a:prstGeom prst="rect">
             <a:avLst/>
@@ -22121,7 +22536,7 @@
         </p:nvSpPr>
         <p:spPr>
           <a:xfrm>
-            <a:off x="5096015" y="3660800"/>
+            <a:off x="5096015" y="3347253"/>
             <a:ext cx="383006" cy="182880"/>
           </a:xfrm>
           <a:prstGeom prst="rect">
@@ -22147,7 +22562,7 @@
                 </a:solidFill>
                 <a:latin typeface="Calibri"/>
               </a:rPr>
-              <a:t>19</a:t>
+              <a:t>44</a:t>
             </a:r>
           </a:p>
         </p:txBody>
@@ -22199,8 +22614,8 @@
         </p:nvSpPr>
         <p:spPr>
           <a:xfrm>
-            <a:off x="5510238" y="2959593"/>
-            <a:ext cx="200126" cy="1136919"/>
+            <a:off x="5510238" y="2884292"/>
+            <a:ext cx="200126" cy="1212220"/>
           </a:xfrm>
           <a:prstGeom prst="rect">
             <a:avLst/>
@@ -22243,7 +22658,7 @@
         </p:nvSpPr>
         <p:spPr>
           <a:xfrm>
-            <a:off x="5418798" y="2758425"/>
+            <a:off x="5418798" y="2683124"/>
             <a:ext cx="383006" cy="182880"/>
           </a:xfrm>
           <a:prstGeom prst="rect">
@@ -22269,7 +22684,7 @@
                 </a:solidFill>
                 <a:latin typeface="Calibri"/>
               </a:rPr>
-              <a:t>92</a:t>
+              <a:t>98</a:t>
             </a:r>
           </a:p>
         </p:txBody>
@@ -22321,8 +22736,8 @@
         </p:nvSpPr>
         <p:spPr>
           <a:xfrm>
-            <a:off x="5833022" y="3154634"/>
-            <a:ext cx="200126" cy="941878"/>
+            <a:off x="5833022" y="2990454"/>
+            <a:ext cx="200126" cy="1106058"/>
           </a:xfrm>
           <a:prstGeom prst="rect">
             <a:avLst/>
@@ -22365,7 +22780,7 @@
         </p:nvSpPr>
         <p:spPr>
           <a:xfrm>
-            <a:off x="5741582" y="2953466"/>
+            <a:off x="5741582" y="2789286"/>
             <a:ext cx="383006" cy="182880"/>
           </a:xfrm>
           <a:prstGeom prst="rect">
@@ -22391,7 +22806,7 @@
                 </a:solidFill>
                 <a:latin typeface="Calibri"/>
               </a:rPr>
-              <a:t>76</a:t>
+              <a:t>90</a:t>
             </a:r>
           </a:p>
         </p:txBody>
@@ -22443,8 +22858,8 @@
         </p:nvSpPr>
         <p:spPr>
           <a:xfrm>
-            <a:off x="6155805" y="3280547"/>
-            <a:ext cx="200126" cy="815965"/>
+            <a:off x="6155805" y="2992923"/>
+            <a:ext cx="200126" cy="1103589"/>
           </a:xfrm>
           <a:prstGeom prst="rect">
             <a:avLst/>
@@ -22487,7 +22902,7 @@
         </p:nvSpPr>
         <p:spPr>
           <a:xfrm>
-            <a:off x="6064365" y="3079379"/>
+            <a:off x="6064365" y="2791755"/>
             <a:ext cx="383006" cy="182880"/>
           </a:xfrm>
           <a:prstGeom prst="rect">
@@ -22513,7 +22928,7 @@
                 </a:solidFill>
                 <a:latin typeface="Calibri"/>
               </a:rPr>
-              <a:t>66</a:t>
+              <a:t>89</a:t>
             </a:r>
           </a:p>
         </p:txBody>
@@ -22565,8 +22980,8 @@
         </p:nvSpPr>
         <p:spPr>
           <a:xfrm>
-            <a:off x="6478588" y="3575578"/>
-            <a:ext cx="200126" cy="520934"/>
+            <a:off x="6478588" y="3237342"/>
+            <a:ext cx="200126" cy="859170"/>
           </a:xfrm>
           <a:prstGeom prst="rect">
             <a:avLst/>
@@ -22609,7 +23024,7 @@
         </p:nvSpPr>
         <p:spPr>
           <a:xfrm>
-            <a:off x="6387148" y="3374410"/>
+            <a:off x="6387148" y="3036174"/>
             <a:ext cx="383006" cy="182880"/>
           </a:xfrm>
           <a:prstGeom prst="rect">
@@ -22635,7 +23050,7 @@
                 </a:solidFill>
                 <a:latin typeface="Calibri"/>
               </a:rPr>
-              <a:t>42</a:t>
+              <a:t>70</a:t>
             </a:r>
           </a:p>
         </p:txBody>
@@ -22687,8 +23102,8 @@
         </p:nvSpPr>
         <p:spPr>
           <a:xfrm>
-            <a:off x="6801371" y="3469416"/>
-            <a:ext cx="200126" cy="627096"/>
+            <a:off x="6801371" y="2960827"/>
+            <a:ext cx="200126" cy="1135685"/>
           </a:xfrm>
           <a:prstGeom prst="rect">
             <a:avLst/>
@@ -22731,7 +23146,7 @@
         </p:nvSpPr>
         <p:spPr>
           <a:xfrm>
-            <a:off x="6709931" y="3268248"/>
+            <a:off x="6709931" y="2759659"/>
             <a:ext cx="383006" cy="182880"/>
           </a:xfrm>
           <a:prstGeom prst="rect">
@@ -22757,7 +23172,7 @@
                 </a:solidFill>
                 <a:latin typeface="Calibri"/>
               </a:rPr>
-              <a:t>51</a:t>
+              <a:t>92</a:t>
             </a:r>
           </a:p>
         </p:txBody>
@@ -22809,8 +23224,8 @@
         </p:nvSpPr>
         <p:spPr>
           <a:xfrm>
-            <a:off x="7124154" y="3204012"/>
-            <a:ext cx="200126" cy="892500"/>
+            <a:off x="7124154" y="2942311"/>
+            <a:ext cx="200126" cy="1154201"/>
           </a:xfrm>
           <a:prstGeom prst="rect">
             <a:avLst/>
@@ -22853,7 +23268,7 @@
         </p:nvSpPr>
         <p:spPr>
           <a:xfrm>
-            <a:off x="7032714" y="3002844"/>
+            <a:off x="7032714" y="2741143"/>
             <a:ext cx="383006" cy="182880"/>
           </a:xfrm>
           <a:prstGeom prst="rect">
@@ -22879,7 +23294,7 @@
                 </a:solidFill>
                 <a:latin typeface="Calibri"/>
               </a:rPr>
-              <a:t>72</a:t>
+              <a:t>94</a:t>
             </a:r>
           </a:p>
         </p:txBody>
@@ -22931,8 +23346,8 @@
         </p:nvSpPr>
         <p:spPr>
           <a:xfrm>
-            <a:off x="7446938" y="3250921"/>
-            <a:ext cx="200126" cy="845591"/>
+            <a:off x="7446938" y="2955889"/>
+            <a:ext cx="200126" cy="1140623"/>
           </a:xfrm>
           <a:prstGeom prst="rect">
             <a:avLst/>
@@ -22975,7 +23390,7 @@
         </p:nvSpPr>
         <p:spPr>
           <a:xfrm>
-            <a:off x="7355498" y="3049753"/>
+            <a:off x="7355498" y="2754721"/>
             <a:ext cx="383006" cy="182880"/>
           </a:xfrm>
           <a:prstGeom prst="rect">
@@ -23001,7 +23416,7 @@
                 </a:solidFill>
                 <a:latin typeface="Calibri"/>
               </a:rPr>
-              <a:t>68</a:t>
+              <a:t>92</a:t>
             </a:r>
           </a:p>
         </p:txBody>
@@ -23100,7 +23515,7 @@
                 </a:solidFill>
                 <a:latin typeface="Calibri"/>
               </a:rPr>
-              <a:t>Each real router is one client. Router 3 sees 19% attacks, router 4 sees 92%: naturally uneven.</a:t>
+              <a:t>Each real router is one client. Router 3 sees 44% attacks, router 4 sees 98%: naturally uneven.</a:t>
             </a:r>
           </a:p>
         </p:txBody>
@@ -31695,7 +32110,7 @@
                 </a:solidFill>
                 <a:latin typeface="Calibri"/>
               </a:rPr>
-              <a:t>A router with more traffic has seen more examples, so its model counts more. Router 10 holds 25% of all flows.</a:t>
+              <a:t>A router with more traffic has seen more examples, so its model counts more. Router 10 holds 26% of all flows.</a:t>
             </a:r>
           </a:p>
         </p:txBody>
@@ -31879,7 +32294,7 @@
                 </a:solidFill>
                 <a:latin typeface="Calibri"/>
               </a:rPr>
-              <a:t>Only the 58,369 weights travel; the 564,007 flows stay on their routers.</a:t>
+              <a:t>Only the 58,369 weights travel; the 275,381 training flows stay on their routers.</a:t>
             </a:r>
           </a:p>
         </p:txBody>
@@ -31971,7 +32386,7 @@
                 </a:solidFill>
                 <a:latin typeface="Calibri"/>
               </a:rPr>
-              <a:t>99.93% over the real routers vs 100.0% centralized.</a:t>
+              <a:t>Test accuracy 99.96% over the real routers vs 100.00% centralized.</a:t>
             </a:r>
           </a:p>
         </p:txBody>

</xml_diff>